<commit_message>
feat: support markdown hyperlinks in reference sources for PPTX and HTML dashboard
</commit_message>
<xml_diff>
--- a/report/2026_06_18_competitive_report.pptx
+++ b/report/2026_06_18_competitive_report.pptx
@@ -4484,14 +4484,22 @@
               <a:spcAft>
                 <a:spcPts val="800"/>
               </a:spcAft>
-              <a:defRPr sz="1200">
+            </a:pPr>
+            <a:r>
+              <a:rPr sz="1200">
                 <a:solidFill>
                   <a:srgbClr val="1E1E1E"/>
                 </a:solidFill>
-              </a:defRPr>
-            </a:pPr>
-            <a:r>
-              <a:t>・   オーケーnews｜4月5月で関西に4店舗を出店/計11店舗体制 流通スーパーニュース. (2026年4月16日).</a:t>
+              </a:rPr>
+              <a:t>・ </a:t>
+            </a:r>
+            <a:r>
+              <a:rPr sz="1200">
+                <a:solidFill>
+                  <a:srgbClr val="1E1E1E"/>
+                </a:solidFill>
+              </a:rPr>
+              <a:t>  オーケーnews｜4月5月で関西に4店舗を出店/計11店舗体制 流通スーパーニュース. (2026年4月16日).</a:t>
             </a:r>
           </a:p>
           <a:p>
@@ -4499,14 +4507,22 @@
               <a:spcAft>
                 <a:spcPts val="800"/>
               </a:spcAft>
-              <a:defRPr sz="1200">
+            </a:pPr>
+            <a:r>
+              <a:rPr sz="1200">
                 <a:solidFill>
                   <a:srgbClr val="1E1E1E"/>
                 </a:solidFill>
-              </a:defRPr>
-            </a:pPr>
-            <a:r>
-              <a:t>・   オーケーが25年兵庫に出す5店を公表 26年には大阪に7店出店 激流オンライン. (2024年12月24日).</a:t>
+              </a:rPr>
+              <a:t>・ </a:t>
+            </a:r>
+            <a:r>
+              <a:rPr sz="1200">
+                <a:solidFill>
+                  <a:srgbClr val="1E1E1E"/>
+                </a:solidFill>
+              </a:rPr>
+              <a:t>  オーケーが25年兵庫に出す5店を公表 26年には大阪に7店出店 激流オンライン. (2024年12月24日).</a:t>
             </a:r>
           </a:p>
           <a:p>
@@ -4514,14 +4530,22 @@
               <a:spcAft>
                 <a:spcPts val="800"/>
               </a:spcAft>
-              <a:defRPr sz="1200">
+            </a:pPr>
+            <a:r>
+              <a:rPr sz="1200">
                 <a:solidFill>
                   <a:srgbClr val="1E1E1E"/>
                 </a:solidFill>
-              </a:defRPr>
-            </a:pPr>
-            <a:r>
-              <a:t>・   オーケーnews｜'26年度関西7店舗出店､4/15南津守店､4/22今川店オープン. (2026年2月24日).</a:t>
+              </a:rPr>
+              <a:t>・ </a:t>
+            </a:r>
+            <a:r>
+              <a:rPr sz="1200">
+                <a:solidFill>
+                  <a:srgbClr val="1E1E1E"/>
+                </a:solidFill>
+              </a:rPr>
+              <a:t>  オーケーnews｜'26年度関西7店舗出店､4/15南津守店､4/22今川店オープン. (2026年2月24日).</a:t>
             </a:r>
           </a:p>
           <a:p>
@@ -4529,14 +4553,22 @@
               <a:spcAft>
                 <a:spcPts val="800"/>
               </a:spcAft>
-              <a:defRPr sz="1200">
+            </a:pPr>
+            <a:r>
+              <a:rPr sz="1200">
                 <a:solidFill>
                   <a:srgbClr val="1E1E1E"/>
                 </a:solidFill>
-              </a:defRPr>
-            </a:pPr>
-            <a:r>
-              <a:t>・   ディスカウント・スーパーマーケット「オーケー南津守店（関西8号店）」2026年4月15日(水)、 「オーケー今川店（関西9号店）」 2026年4月22日(水) 連続出店！ ～2026年は大阪府での展開を加速します！～. (2026年2月24日).</a:t>
+              </a:rPr>
+              <a:t>・ </a:t>
+            </a:r>
+            <a:r>
+              <a:rPr sz="1200">
+                <a:solidFill>
+                  <a:srgbClr val="1E1E1E"/>
+                </a:solidFill>
+              </a:rPr>
+              <a:t>  ディスカウント・スーパーマーケット「オーケー南津守店（関西8号店）」2026年4月15日(水)、 「オーケー今川店（関西9号店）」 2026年4月22日(水) 連続出店！ ～2026年は大阪府での展開を加速します！～. (2026年2月24日).</a:t>
             </a:r>
           </a:p>
           <a:p>
@@ -4544,14 +4576,22 @@
               <a:spcAft>
                 <a:spcPts val="800"/>
               </a:spcAft>
-              <a:defRPr sz="1200">
+            </a:pPr>
+            <a:r>
+              <a:rPr sz="1200">
                 <a:solidFill>
                   <a:srgbClr val="1E1E1E"/>
                 </a:solidFill>
-              </a:defRPr>
-            </a:pPr>
-            <a:r>
-              <a:t>・   オーケー／25年兵庫県5店舗、26年大阪府7店舗オープン \| 流通ニュース. (2024年12月23日).</a:t>
+              </a:rPr>
+              <a:t>・ </a:t>
+            </a:r>
+            <a:r>
+              <a:rPr sz="1200">
+                <a:solidFill>
+                  <a:srgbClr val="1E1E1E"/>
+                </a:solidFill>
+              </a:rPr>
+              <a:t>  オーケー／25年兵庫県5店舗、26年大阪府7店舗オープン \| 流通ニュース. (2024年12月23日).</a:t>
             </a:r>
           </a:p>
           <a:p>
@@ -4559,14 +4599,22 @@
               <a:spcAft>
                 <a:spcPts val="800"/>
               </a:spcAft>
-              <a:defRPr sz="1200">
+            </a:pPr>
+            <a:r>
+              <a:rPr sz="1200">
                 <a:solidFill>
                   <a:srgbClr val="1E1E1E"/>
                 </a:solidFill>
-              </a:defRPr>
-            </a:pPr>
-            <a:r>
-              <a:t>・   ディスカウント・スーパーマーケット「オーケー」 大阪府での展開を加速！5月に「大東新田西町店」「豊中穂積店」を連続出店 ～2026年度は大阪府内に計7店舗の出店を予定. (2026年4月14日).</a:t>
+              </a:rPr>
+              <a:t>・ </a:t>
+            </a:r>
+            <a:r>
+              <a:rPr sz="1200">
+                <a:solidFill>
+                  <a:srgbClr val="1E1E1E"/>
+                </a:solidFill>
+              </a:rPr>
+              <a:t>  ディスカウント・スーパーマーケット「オーケー」 大阪府での展開を加速！5月に「大東新田西町店」「豊中穂積店」を連続出店 ～2026年度は大阪府内に計7店舗の出店を予定. (2026年4月14日).</a:t>
             </a:r>
           </a:p>
           <a:p>
@@ -4574,14 +4622,22 @@
               <a:spcAft>
                 <a:spcPts val="800"/>
               </a:spcAft>
-              <a:defRPr sz="1200">
+            </a:pPr>
+            <a:r>
+              <a:rPr sz="1200">
                 <a:solidFill>
                   <a:srgbClr val="1E1E1E"/>
                 </a:solidFill>
-              </a:defRPr>
-            </a:pPr>
-            <a:r>
-              <a:t>・   成城石井、大阪府堺市に「成城石井 イオンモール堺北花田店」6月18日オープン. (2026年6月17日).</a:t>
+              </a:rPr>
+              <a:t>・ </a:t>
+            </a:r>
+            <a:r>
+              <a:rPr sz="1200">
+                <a:solidFill>
+                  <a:srgbClr val="1E1E1E"/>
+                </a:solidFill>
+              </a:rPr>
+              <a:t>  成城石井、大阪府堺市に「成城石井 イオンモール堺北花田店」6月18日オープン. (2026年6月17日).</a:t>
             </a:r>
           </a:p>
           <a:p>
@@ -4589,14 +4645,22 @@
               <a:spcAft>
                 <a:spcPts val="800"/>
               </a:spcAft>
-              <a:defRPr sz="1200">
+            </a:pPr>
+            <a:r>
+              <a:rPr sz="1200">
                 <a:solidFill>
                   <a:srgbClr val="1E1E1E"/>
                 </a:solidFill>
-              </a:defRPr>
-            </a:pPr>
-            <a:r>
-              <a:t>・   関西地方 \| 出店ウォッチ. (2026年6月7日).</a:t>
+              </a:rPr>
+              <a:t>・ </a:t>
+            </a:r>
+            <a:r>
+              <a:rPr sz="1200">
+                <a:solidFill>
+                  <a:srgbClr val="1E1E1E"/>
+                </a:solidFill>
+              </a:rPr>
+              <a:t>  関西地方 \| 出店ウォッチ. (2026年6月7日).</a:t>
             </a:r>
           </a:p>
           <a:p>
@@ -4604,14 +4668,22 @@
               <a:spcAft>
                 <a:spcPts val="800"/>
               </a:spcAft>
-              <a:defRPr sz="1200">
+            </a:pPr>
+            <a:r>
+              <a:rPr sz="1200">
                 <a:solidFill>
                   <a:srgbClr val="1E1E1E"/>
                 </a:solidFill>
-              </a:defRPr>
-            </a:pPr>
-            <a:r>
-              <a:t>・   成城石井 イオンモール堺北花田店｣6/18オープン 流通スーパーニュース. (2026年6月11日).</a:t>
+              </a:rPr>
+              <a:t>・ </a:t>
+            </a:r>
+            <a:r>
+              <a:rPr sz="1200">
+                <a:solidFill>
+                  <a:srgbClr val="1E1E1E"/>
+                </a:solidFill>
+              </a:rPr>
+              <a:t>  成城石井 イオンモール堺北花田店｣6/18オープン 流通スーパーニュース. (2026年6月11日).</a:t>
             </a:r>
           </a:p>
           <a:p>
@@ -4619,14 +4691,22 @@
               <a:spcAft>
                 <a:spcPts val="800"/>
               </a:spcAft>
-              <a:defRPr sz="1200">
+            </a:pPr>
+            <a:r>
+              <a:rPr sz="1200">
                 <a:solidFill>
                   <a:srgbClr val="1E1E1E"/>
                 </a:solidFill>
-              </a:defRPr>
-            </a:pPr>
-            <a:r>
-              <a:t>・   成城石井イオンモール堺北花田店、2026年6月18日開店－郊外型店舗の強化進める成城石井、さらなる狭小店展開 \| 都市商業研究所. (2026年6月17日).</a:t>
+              </a:rPr>
+              <a:t>・ </a:t>
+            </a:r>
+            <a:r>
+              <a:rPr sz="1200">
+                <a:solidFill>
+                  <a:srgbClr val="1E1E1E"/>
+                </a:solidFill>
+              </a:rPr>
+              <a:t>  成城石井イオンモール堺北花田店、2026年6月18日開店－郊外型店舗の強化進める成城石井、さらなる狭小店展開 \| 都市商業研究所. (2026年6月17日).</a:t>
             </a:r>
           </a:p>
           <a:p>
@@ -4634,14 +4714,22 @@
               <a:spcAft>
                 <a:spcPts val="800"/>
               </a:spcAft>
-              <a:defRPr sz="1200">
+            </a:pPr>
+            <a:r>
+              <a:rPr sz="1200">
                 <a:solidFill>
                   <a:srgbClr val="1E1E1E"/>
                 </a:solidFill>
-              </a:defRPr>
-            </a:pPr>
-            <a:r>
-              <a:t>・   【堺市】「成城石井 イオンモール堺北花田店」が6月18日にオープン 御堂筋線・北花田駅至近のイオンモール1階に出店. (2026年6月15日).</a:t>
+              </a:rPr>
+              <a:t>・ </a:t>
+            </a:r>
+            <a:r>
+              <a:rPr sz="1200">
+                <a:solidFill>
+                  <a:srgbClr val="1E1E1E"/>
+                </a:solidFill>
+              </a:rPr>
+              <a:t>  【堺市】「成城石井 イオンモール堺北花田店」が6月18日にオープン 御堂筋線・北花田駅至近のイオンモール1階に出店. (2026年6月15日).</a:t>
             </a:r>
           </a:p>
         </p:txBody>

</xml_diff>

<commit_message>
feat: strictly request and robustly parse markdown hyperlinks in references for HTML and PPTX
</commit_message>
<xml_diff>
--- a/report/2026_06_18_competitive_report.pptx
+++ b/report/2026_06_18_competitive_report.pptx
@@ -3238,7 +3238,7 @@
               </a:defRPr>
             </a:pPr>
             <a:r>
-              <a:t>・   高級スーパーマーケットの競合環境において、新たな出店計画が複数判明した。特に、高品質・高価格帯市場での直接的な競争激化が見込まれる。</a:t>
+              <a:t>・   高級スーパーマーケットの競合環境において、いかりスーパーの顧客層と重複する可能性のあるエリアで、成城石井の新規出店が判明した。</a:t>
             </a:r>
           </a:p>
           <a:p>
@@ -3253,7 +3253,7 @@
               </a:defRPr>
             </a:pPr>
             <a:r>
-              <a:t>・   ヤマダストアーは、2027年春に兵庫県宝塚市に新店舗をオープンする計画であり、いかりスーパーの顧客層と重複する地域での競合が強まる。</a:t>
+              <a:t>・   成城石井は2026年6月18日に大阪府堺市にイオンモール堺北花田店をオープンし、いかりスーパーの既存店舗と競合する可能性がある。</a:t>
             </a:r>
           </a:p>
           <a:p>
@@ -3268,7 +3268,7 @@
               </a:defRPr>
             </a:pPr>
             <a:r>
-              <a:t>・   成城石井は、本日2026年6月18日に大阪府堺市のイオンモール堺北花田店に新規出店し、都市部での高品質スーパー市場での競争がさらに激化する。</a:t>
+              <a:t>・   ヤマダストアーは2026年冬に大阪梅田の大丸梅田店地下に新規出店を予定しており、都市部の高品質スーパー市場での競争が引き続き激化する見込みである。</a:t>
             </a:r>
           </a:p>
           <a:p>
@@ -3283,7 +3283,22 @@
               </a:defRPr>
             </a:pPr>
             <a:r>
-              <a:t>・   ディスカウントスーパーのオーケーは、2026年後半に大阪府内で2店舗の新規出店（高槻赤大路店、長吉店）を予定しており、2027年以降も関西エリアでの積極的な展開を継続する方針を示しており、広範な価格帯での競争圧力が上昇する。</a:t>
+              <a:t>・   阪急オアシスは豊中駅前店を2026年6月26日に「阪急OASISマルシェ豊中駅前店」としてリニューアルオープンするほか、服部西店が2026年7月7日から臨時休業（改装の可能性あり）を予定しており、これらリニューアル店舗が地域での競争力を高める可能性がある。</a:t>
+            </a:r>
+          </a:p>
+          <a:p>
+            <a:pPr>
+              <a:spcAft>
+                <a:spcPts val="1600"/>
+              </a:spcAft>
+              <a:defRPr sz="1800">
+                <a:solidFill>
+                  <a:srgbClr val="1E1E1E"/>
+                </a:solidFill>
+              </a:defRPr>
+            </a:pPr>
+            <a:r>
+              <a:t>・   関西スーパー西郷店が2026年6月30日から臨時休業を予定しており、短期間ながら周辺エリアの顧客流動に影響を与える可能性がある。</a:t>
             </a:r>
           </a:p>
         </p:txBody>
@@ -3367,7 +3382,7 @@
                 <a:gridCol w="1371600"/>
                 <a:gridCol w="4416552"/>
               </a:tblGrid>
-              <a:tr h="792480">
+              <a:tr h="679268">
                 <a:tc>
                   <a:txBody>
                     <a:bodyPr/>
@@ -3507,7 +3522,7 @@
                   </a:tcPr>
                 </a:tc>
               </a:tr>
-              <a:tr h="792480">
+              <a:tr h="679268">
                 <a:tc>
                   <a:txBody>
                     <a:bodyPr/>
@@ -3647,7 +3662,7 @@
                   </a:tcPr>
                 </a:tc>
               </a:tr>
-              <a:tr h="792480">
+              <a:tr h="679268">
                 <a:tc>
                   <a:txBody>
                     <a:bodyPr/>
@@ -3756,14 +3771,14 @@
                         </a:defRPr>
                       </a:pPr>
                       <a:r>
-                        <a:t>Osaka Metro御堂筋線北花田駅直結のイオンモール堺北花田1階に約38坪の規模でオープン。惣菜、デザート、パン、グロサリーなど高品質商品を幅広く展開する。</a:t>
+                        <a:t>Osaka Metro御堂筋線「北花田駅」近くのショッピングセンター「イオンモール堺北花田」1階にオープン。売場面積は約38坪で、惣菜やデザート、パン、グロサリー、酒類など幅広い商品を取りそろえる。</a:t>
                       </a:r>
                     </a:p>
                   </a:txBody>
                   <a:tcPr/>
                 </a:tc>
               </a:tr>
-              <a:tr h="792480">
+              <a:tr h="679268">
                 <a:tc>
                   <a:txBody>
                     <a:bodyPr/>
@@ -3777,7 +3792,7 @@
                         </a:defRPr>
                       </a:pPr>
                       <a:r>
-                        <a:t>大阪府高槻市</a:t>
+                        <a:t>大阪府大阪市北区</a:t>
                       </a:r>
                     </a:p>
                   </a:txBody>
@@ -3800,7 +3815,7 @@
                         </a:defRPr>
                       </a:pPr>
                       <a:r>
-                        <a:t>オーケー 高槻赤大路店</a:t>
+                        <a:t>ヤマダストアー 大阪梅田店（大丸梅田店B2階）</a:t>
                       </a:r>
                     </a:p>
                   </a:txBody>
@@ -3823,263 +3838,7 @@
                         </a:defRPr>
                       </a:pPr>
                       <a:r>
-                        <a:t>2026年8月下旬</a:t>
-                      </a:r>
-                    </a:p>
-                  </a:txBody>
-                  <a:tcPr>
-                    <a:solidFill>
-                      <a:srgbClr val="F5F5F5"/>
-                    </a:solidFill>
-                  </a:tcPr>
-                </a:tc>
-                <a:tc>
-                  <a:txBody>
-                    <a:bodyPr/>
-                    <a:lstStyle/>
-                    <a:p>
-                      <a:pPr>
-                        <a:defRPr sz="950">
-                          <a:solidFill>
-                            <a:srgbClr val="1E1E1E"/>
-                          </a:solidFill>
-                        </a:defRPr>
-                      </a:pPr>
-                      <a:r>
-                        <a:t>新規出店</a:t>
-                      </a:r>
-                    </a:p>
-                  </a:txBody>
-                  <a:tcPr>
-                    <a:solidFill>
-                      <a:srgbClr val="F5F5F5"/>
-                    </a:solidFill>
-                  </a:tcPr>
-                </a:tc>
-                <a:tc>
-                  <a:txBody>
-                    <a:bodyPr/>
-                    <a:lstStyle/>
-                    <a:p>
-                      <a:pPr>
-                        <a:defRPr sz="950">
-                          <a:solidFill>
-                            <a:srgbClr val="1E1E1E"/>
-                          </a:solidFill>
-                        </a:defRPr>
-                      </a:pPr>
-                      <a:r>
-                        <a:t>中</a:t>
-                      </a:r>
-                    </a:p>
-                  </a:txBody>
-                  <a:tcPr>
-                    <a:solidFill>
-                      <a:srgbClr val="F5F5F5"/>
-                    </a:solidFill>
-                  </a:tcPr>
-                </a:tc>
-                <a:tc>
-                  <a:txBody>
-                    <a:bodyPr/>
-                    <a:lstStyle/>
-                    <a:p>
-                      <a:pPr>
-                        <a:defRPr sz="950">
-                          <a:solidFill>
-                            <a:srgbClr val="1E1E1E"/>
-                          </a:solidFill>
-                        </a:defRPr>
-                      </a:pPr>
-                      <a:r>
-                        <a:t>オーケーは2026年度に大阪府内で計7店舗の出店を予定しており、その一環として8月下旬に高槻赤大路店をオープンする。</a:t>
-                      </a:r>
-                    </a:p>
-                  </a:txBody>
-                  <a:tcPr>
-                    <a:solidFill>
-                      <a:srgbClr val="F5F5F5"/>
-                    </a:solidFill>
-                  </a:tcPr>
-                </a:tc>
-              </a:tr>
-              <a:tr h="792480">
-                <a:tc>
-                  <a:txBody>
-                    <a:bodyPr/>
-                    <a:lstStyle/>
-                    <a:p>
-                      <a:pPr>
-                        <a:defRPr sz="950">
-                          <a:solidFill>
-                            <a:srgbClr val="1E1E1E"/>
-                          </a:solidFill>
-                        </a:defRPr>
-                      </a:pPr>
-                      <a:r>
-                        <a:t>大阪府大阪市</a:t>
-                      </a:r>
-                    </a:p>
-                  </a:txBody>
-                  <a:tcPr/>
-                </a:tc>
-                <a:tc>
-                  <a:txBody>
-                    <a:bodyPr/>
-                    <a:lstStyle/>
-                    <a:p>
-                      <a:pPr>
-                        <a:defRPr sz="950">
-                          <a:solidFill>
-                            <a:srgbClr val="1E1E1E"/>
-                          </a:solidFill>
-                        </a:defRPr>
-                      </a:pPr>
-                      <a:r>
-                        <a:t>オーケー 長吉店</a:t>
-                      </a:r>
-                    </a:p>
-                  </a:txBody>
-                  <a:tcPr/>
-                </a:tc>
-                <a:tc>
-                  <a:txBody>
-                    <a:bodyPr/>
-                    <a:lstStyle/>
-                    <a:p>
-                      <a:pPr>
-                        <a:defRPr sz="950">
-                          <a:solidFill>
-                            <a:srgbClr val="1E1E1E"/>
-                          </a:solidFill>
-                        </a:defRPr>
-                      </a:pPr>
-                      <a:r>
-                        <a:t>2026年11月中旬</a:t>
-                      </a:r>
-                    </a:p>
-                  </a:txBody>
-                  <a:tcPr/>
-                </a:tc>
-                <a:tc>
-                  <a:txBody>
-                    <a:bodyPr/>
-                    <a:lstStyle/>
-                    <a:p>
-                      <a:pPr>
-                        <a:defRPr sz="950">
-                          <a:solidFill>
-                            <a:srgbClr val="1E1E1E"/>
-                          </a:solidFill>
-                        </a:defRPr>
-                      </a:pPr>
-                      <a:r>
-                        <a:t>新規出店</a:t>
-                      </a:r>
-                    </a:p>
-                  </a:txBody>
-                  <a:tcPr/>
-                </a:tc>
-                <a:tc>
-                  <a:txBody>
-                    <a:bodyPr/>
-                    <a:lstStyle/>
-                    <a:p>
-                      <a:pPr>
-                        <a:defRPr sz="950">
-                          <a:solidFill>
-                            <a:srgbClr val="1E1E1E"/>
-                          </a:solidFill>
-                        </a:defRPr>
-                      </a:pPr>
-                      <a:r>
-                        <a:t>中</a:t>
-                      </a:r>
-                    </a:p>
-                  </a:txBody>
-                  <a:tcPr/>
-                </a:tc>
-                <a:tc>
-                  <a:txBody>
-                    <a:bodyPr/>
-                    <a:lstStyle/>
-                    <a:p>
-                      <a:pPr>
-                        <a:defRPr sz="950">
-                          <a:solidFill>
-                            <a:srgbClr val="1E1E1E"/>
-                          </a:solidFill>
-                        </a:defRPr>
-                      </a:pPr>
-                      <a:r>
-                        <a:t>2026年度の大阪府内での出店計画に含まれており、11月中旬にオープン予定。</a:t>
-                      </a:r>
-                    </a:p>
-                  </a:txBody>
-                  <a:tcPr/>
-                </a:tc>
-              </a:tr>
-              <a:tr h="792480">
-                <a:tc>
-                  <a:txBody>
-                    <a:bodyPr/>
-                    <a:lstStyle/>
-                    <a:p>
-                      <a:pPr>
-                        <a:defRPr sz="950">
-                          <a:solidFill>
-                            <a:srgbClr val="1E1E1E"/>
-                          </a:solidFill>
-                        </a:defRPr>
-                      </a:pPr>
-                      <a:r>
-                        <a:t>兵庫県宝塚市</a:t>
-                      </a:r>
-                    </a:p>
-                  </a:txBody>
-                  <a:tcPr>
-                    <a:solidFill>
-                      <a:srgbClr val="F5F5F5"/>
-                    </a:solidFill>
-                  </a:tcPr>
-                </a:tc>
-                <a:tc>
-                  <a:txBody>
-                    <a:bodyPr/>
-                    <a:lstStyle/>
-                    <a:p>
-                      <a:pPr>
-                        <a:defRPr sz="950">
-                          <a:solidFill>
-                            <a:srgbClr val="1E1E1E"/>
-                          </a:solidFill>
-                        </a:defRPr>
-                      </a:pPr>
-                      <a:r>
-                        <a:t>ヤマダストアー 宝塚店（仮称）</a:t>
-                      </a:r>
-                    </a:p>
-                  </a:txBody>
-                  <a:tcPr>
-                    <a:solidFill>
-                      <a:srgbClr val="F5F5F5"/>
-                    </a:solidFill>
-                  </a:tcPr>
-                </a:tc>
-                <a:tc>
-                  <a:txBody>
-                    <a:bodyPr/>
-                    <a:lstStyle/>
-                    <a:p>
-                      <a:pPr>
-                        <a:defRPr sz="950">
-                          <a:solidFill>
-                            <a:srgbClr val="1E1E1E"/>
-                          </a:solidFill>
-                        </a:defRPr>
-                      </a:pPr>
-                      <a:r>
-                        <a:t>2027年春</a:t>
+                        <a:t>2026年冬</a:t>
                       </a:r>
                     </a:p>
                   </a:txBody>
@@ -4148,7 +3907,7 @@
                         </a:defRPr>
                       </a:pPr>
                       <a:r>
-                        <a:t>兵庫県宝塚市伊孑志4丁目のNTT社員寮跡地に、こだわりの高品質スーパーマーケットとしてオープン予定。</a:t>
+                        <a:t>兵庫県を中心に高品質・こだわり商品を展開するヤマダストアーが、JR大阪駅直結の大丸梅田店の地下食品フロアにオープン予定。</a:t>
                       </a:r>
                     </a:p>
                   </a:txBody>
@@ -4157,6 +3916,367 @@
                       <a:srgbClr val="F5F5F5"/>
                     </a:solidFill>
                   </a:tcPr>
+                </a:tc>
+              </a:tr>
+              <a:tr h="679268">
+                <a:tc>
+                  <a:txBody>
+                    <a:bodyPr/>
+                    <a:lstStyle/>
+                    <a:p>
+                      <a:pPr>
+                        <a:defRPr sz="950">
+                          <a:solidFill>
+                            <a:srgbClr val="1E1E1E"/>
+                          </a:solidFill>
+                        </a:defRPr>
+                      </a:pPr>
+                      <a:r>
+                        <a:t>大阪府豊中市</a:t>
+                      </a:r>
+                    </a:p>
+                  </a:txBody>
+                  <a:tcPr/>
+                </a:tc>
+                <a:tc>
+                  <a:txBody>
+                    <a:bodyPr/>
+                    <a:lstStyle/>
+                    <a:p>
+                      <a:pPr>
+                        <a:defRPr sz="950">
+                          <a:solidFill>
+                            <a:srgbClr val="1E1E1E"/>
+                          </a:solidFill>
+                        </a:defRPr>
+                      </a:pPr>
+                      <a:r>
+                        <a:t>阪急OASISマルシェ豊中駅前店</a:t>
+                      </a:r>
+                    </a:p>
+                  </a:txBody>
+                  <a:tcPr/>
+                </a:tc>
+                <a:tc>
+                  <a:txBody>
+                    <a:bodyPr/>
+                    <a:lstStyle/>
+                    <a:p>
+                      <a:pPr>
+                        <a:defRPr sz="950">
+                          <a:solidFill>
+                            <a:srgbClr val="1E1E1E"/>
+                          </a:solidFill>
+                        </a:defRPr>
+                      </a:pPr>
+                      <a:r>
+                        <a:t>2026年6月26日</a:t>
+                      </a:r>
+                    </a:p>
+                  </a:txBody>
+                  <a:tcPr/>
+                </a:tc>
+                <a:tc>
+                  <a:txBody>
+                    <a:bodyPr/>
+                    <a:lstStyle/>
+                    <a:p>
+                      <a:pPr>
+                        <a:defRPr sz="950">
+                          <a:solidFill>
+                            <a:srgbClr val="1E1E1E"/>
+                          </a:solidFill>
+                        </a:defRPr>
+                      </a:pPr>
+                      <a:r>
+                        <a:t>リニューアルオープン</a:t>
+                      </a:r>
+                    </a:p>
+                  </a:txBody>
+                  <a:tcPr/>
+                </a:tc>
+                <a:tc>
+                  <a:txBody>
+                    <a:bodyPr/>
+                    <a:lstStyle/>
+                    <a:p>
+                      <a:pPr>
+                        <a:defRPr sz="950">
+                          <a:solidFill>
+                            <a:srgbClr val="1E1E1E"/>
+                          </a:solidFill>
+                        </a:defRPr>
+                      </a:pPr>
+                      <a:r>
+                        <a:t>中</a:t>
+                      </a:r>
+                    </a:p>
+                  </a:txBody>
+                  <a:tcPr/>
+                </a:tc>
+                <a:tc>
+                  <a:txBody>
+                    <a:bodyPr/>
+                    <a:lstStyle/>
+                    <a:p>
+                      <a:pPr>
+                        <a:defRPr sz="950">
+                          <a:solidFill>
+                            <a:srgbClr val="1E1E1E"/>
+                          </a:solidFill>
+                        </a:defRPr>
+                      </a:pPr>
+                      <a:r>
+                        <a:t>阪急オアシス豊中駅前店が6月15日18時に一時休業し、6月26日に「価値訴求型」と「価格訴求型」を融合した「阪急OASISマルシェ豊中駅前店」としてリニューアルオープンする。</a:t>
+                      </a:r>
+                    </a:p>
+                  </a:txBody>
+                  <a:tcPr/>
+                </a:tc>
+              </a:tr>
+              <a:tr h="679268">
+                <a:tc>
+                  <a:txBody>
+                    <a:bodyPr/>
+                    <a:lstStyle/>
+                    <a:p>
+                      <a:pPr>
+                        <a:defRPr sz="950">
+                          <a:solidFill>
+                            <a:srgbClr val="1E1E1E"/>
+                          </a:solidFill>
+                        </a:defRPr>
+                      </a:pPr>
+                      <a:r>
+                        <a:t>大阪府豊中市</a:t>
+                      </a:r>
+                    </a:p>
+                  </a:txBody>
+                  <a:tcPr>
+                    <a:solidFill>
+                      <a:srgbClr val="F5F5F5"/>
+                    </a:solidFill>
+                  </a:tcPr>
+                </a:tc>
+                <a:tc>
+                  <a:txBody>
+                    <a:bodyPr/>
+                    <a:lstStyle/>
+                    <a:p>
+                      <a:pPr>
+                        <a:defRPr sz="950">
+                          <a:solidFill>
+                            <a:srgbClr val="1E1E1E"/>
+                          </a:solidFill>
+                        </a:defRPr>
+                      </a:pPr>
+                      <a:r>
+                        <a:t>阪急オアシス 服部西店</a:t>
+                      </a:r>
+                    </a:p>
+                  </a:txBody>
+                  <a:tcPr>
+                    <a:solidFill>
+                      <a:srgbClr val="F5F5F5"/>
+                    </a:solidFill>
+                  </a:tcPr>
+                </a:tc>
+                <a:tc>
+                  <a:txBody>
+                    <a:bodyPr/>
+                    <a:lstStyle/>
+                    <a:p>
+                      <a:pPr>
+                        <a:defRPr sz="950">
+                          <a:solidFill>
+                            <a:srgbClr val="1E1E1E"/>
+                          </a:solidFill>
+                        </a:defRPr>
+                      </a:pPr>
+                      <a:r>
+                        <a:t>2026年7月7日～7月16日</a:t>
+                      </a:r>
+                    </a:p>
+                  </a:txBody>
+                  <a:tcPr>
+                    <a:solidFill>
+                      <a:srgbClr val="F5F5F5"/>
+                    </a:solidFill>
+                  </a:tcPr>
+                </a:tc>
+                <a:tc>
+                  <a:txBody>
+                    <a:bodyPr/>
+                    <a:lstStyle/>
+                    <a:p>
+                      <a:pPr>
+                        <a:defRPr sz="950">
+                          <a:solidFill>
+                            <a:srgbClr val="1E1E1E"/>
+                          </a:solidFill>
+                        </a:defRPr>
+                      </a:pPr>
+                      <a:r>
+                        <a:t>臨時休業（改装の可能性あり）</a:t>
+                      </a:r>
+                    </a:p>
+                  </a:txBody>
+                  <a:tcPr>
+                    <a:solidFill>
+                      <a:srgbClr val="F5F5F5"/>
+                    </a:solidFill>
+                  </a:tcPr>
+                </a:tc>
+                <a:tc>
+                  <a:txBody>
+                    <a:bodyPr/>
+                    <a:lstStyle/>
+                    <a:p>
+                      <a:pPr>
+                        <a:defRPr sz="950">
+                          <a:solidFill>
+                            <a:srgbClr val="1E1E1E"/>
+                          </a:solidFill>
+                        </a:defRPr>
+                      </a:pPr>
+                      <a:r>
+                        <a:t>低</a:t>
+                      </a:r>
+                    </a:p>
+                  </a:txBody>
+                  <a:tcPr>
+                    <a:solidFill>
+                      <a:srgbClr val="F5F5F5"/>
+                    </a:solidFill>
+                  </a:tcPr>
+                </a:tc>
+                <a:tc>
+                  <a:txBody>
+                    <a:bodyPr/>
+                    <a:lstStyle/>
+                    <a:p>
+                      <a:pPr>
+                        <a:defRPr sz="950">
+                          <a:solidFill>
+                            <a:srgbClr val="1E1E1E"/>
+                          </a:solidFill>
+                        </a:defRPr>
+                      </a:pPr>
+                      <a:r>
+                        <a:t>阪急オアシス服部西店が設備点検・改装のため臨時休業予定。</a:t>
+                      </a:r>
+                    </a:p>
+                  </a:txBody>
+                  <a:tcPr>
+                    <a:solidFill>
+                      <a:srgbClr val="F5F5F5"/>
+                    </a:solidFill>
+                  </a:tcPr>
+                </a:tc>
+              </a:tr>
+              <a:tr h="679272">
+                <a:tc>
+                  <a:txBody>
+                    <a:bodyPr/>
+                    <a:lstStyle/>
+                    <a:p>
+                      <a:pPr>
+                        <a:defRPr sz="950">
+                          <a:solidFill>
+                            <a:srgbClr val="1E1E1E"/>
+                          </a:solidFill>
+                        </a:defRPr>
+                      </a:pPr>
+                      <a:r>
+                        <a:t>兵庫県神戸市灘区</a:t>
+                      </a:r>
+                    </a:p>
+                  </a:txBody>
+                  <a:tcPr/>
+                </a:tc>
+                <a:tc>
+                  <a:txBody>
+                    <a:bodyPr/>
+                    <a:lstStyle/>
+                    <a:p>
+                      <a:pPr>
+                        <a:defRPr sz="950">
+                          <a:solidFill>
+                            <a:srgbClr val="1E1E1E"/>
+                          </a:solidFill>
+                        </a:defRPr>
+                      </a:pPr>
+                      <a:r>
+                        <a:t>関西スーパー 西郷店</a:t>
+                      </a:r>
+                    </a:p>
+                  </a:txBody>
+                  <a:tcPr/>
+                </a:tc>
+                <a:tc>
+                  <a:txBody>
+                    <a:bodyPr/>
+                    <a:lstStyle/>
+                    <a:p>
+                      <a:pPr>
+                        <a:defRPr sz="950">
+                          <a:solidFill>
+                            <a:srgbClr val="1E1E1E"/>
+                          </a:solidFill>
+                        </a:defRPr>
+                      </a:pPr>
+                      <a:r>
+                        <a:t>2026年6月30日～7月2日</a:t>
+                      </a:r>
+                    </a:p>
+                  </a:txBody>
+                  <a:tcPr/>
+                </a:tc>
+                <a:tc>
+                  <a:txBody>
+                    <a:bodyPr/>
+                    <a:lstStyle/>
+                    <a:p>
+                      <a:pPr>
+                        <a:defRPr sz="950">
+                          <a:solidFill>
+                            <a:srgbClr val="1E1E1E"/>
+                          </a:solidFill>
+                        </a:defRPr>
+                      </a:pPr>
+                      <a:r>
+                        <a:t>臨時休業</a:t>
+                      </a:r>
+                    </a:p>
+                  </a:txBody>
+                  <a:tcPr/>
+                </a:tc>
+                <a:tc>
+                  <a:txBody>
+                    <a:bodyPr/>
+                    <a:lstStyle/>
+                    <a:p>
+                      <a:pPr>
+                        <a:defRPr sz="950">
+                          <a:solidFill>
+                            <a:srgbClr val="1E1E1E"/>
+                          </a:solidFill>
+                        </a:defRPr>
+                      </a:pPr>
+                      <a:r>
+                        <a:t>低</a:t>
+                      </a:r>
+                    </a:p>
+                  </a:txBody>
+                  <a:tcPr/>
+                </a:tc>
+                <a:tc>
+                  <a:txBody>
+                    <a:bodyPr/>
+                    <a:lstStyle/>
+                    <a:p/>
+                  </a:txBody>
+                  <a:tcPr/>
                 </a:tc>
               </a:tr>
             </a:tbl>
@@ -4249,7 +4369,7 @@
               </a:defRPr>
             </a:pPr>
             <a:r>
-              <a:t>*   本日（2026年6月18日）オープンした成城石井イオンモール堺北花田店は、いかりスーパーの既存店舗とはやや離れるものの、北花田駅直結という利便性の高い立地で、いかりスーパーがターゲットとする高品質志向の顧客層の一部を吸引する可能性がある。</a:t>
+              <a:t>*   成城石井イオンモール堺北花田店は、Osaka Metro御堂筋線北花田駅に直結するイオンモール内への出店であり、いかりスーパーの既存店舗が近隣にない場合でも、広域からの集客が見込まれる商業施設への出店であるため、いかりスーパーの品質志向の顧客層との競合が発生する可能性がある。</a:t>
             </a:r>
           </a:p>
           <a:p>
@@ -4264,7 +4384,7 @@
               </a:defRPr>
             </a:pPr>
             <a:r>
-              <a:t>*   2027年春に宝塚市に新規出店するヤマダストアー宝塚店は、いかりスーパーの宝塚エリア店舗（例: いかり宝塚店など）にとって直接的な競合となる。ヤマダストアーも高品質・こだわり商品を強みとするため、このエリアでの競争激化は避けられない。</a:t>
+              <a:t>*   ヤマダストアー大阪梅田店は、大阪駅直結という非常に高い利便性を持つ商業施設内に出店するため、いかりJR大阪駅店や近隣の梅田エリアのいかり店舗にとって、高品質志向の顧客層を巡る直接的な競合となる。</a:t>
             </a:r>
           </a:p>
           <a:p>
@@ -4279,7 +4399,22 @@
               </a:defRPr>
             </a:pPr>
             <a:r>
-              <a:t>*   オーケーの高槻赤大路店（2026年8月下旬）および長吉店（2026年11月中旬）の出店は、大阪府内におけるオーケーの店舗網をさらに拡大させるものであり、広範囲で価格競争を激化させる要因となり得る。いかりスーパーとは異なる価格帯の競合ではあるが、日常使いの需要を奪われる可能性があり、間接的な影響は大きい。</a:t>
+              <a:t>*   阪急OASISマルシェ豊中駅前店のリニューアルは、いかりスーパー豊中店と同一地域での競争力を強化するものであり、特に「マルシェ」タイプへの転換は品揃えや店舗体験の差別化を試みるものと推測される。</a:t>
+            </a:r>
+          </a:p>
+          <a:p>
+            <a:pPr>
+              <a:spcAft>
+                <a:spcPts val="1400"/>
+              </a:spcAft>
+              <a:defRPr sz="1400">
+                <a:solidFill>
+                  <a:srgbClr val="1E1E1E"/>
+                </a:solidFill>
+              </a:defRPr>
+            </a:pPr>
+            <a:r>
+              <a:t>*   阪急オアシス服部西店および関西スーパー西郷店の臨時休業は一時的なものではあるが、周辺のいかりスーパー店舗への短期的な顧客流入や、休業後のリニューアル内容によっては中長期的な競合環境の変化に繋がる可能性がある。</a:t>
             </a:r>
           </a:p>
         </p:txBody>
@@ -4370,7 +4505,7 @@
               </a:defRPr>
             </a:pPr>
             <a:r>
-              <a:t>*   本日開業した「成城石井 イオンモール堺北花田店」の出店は、いかりスーパーの大阪市内南部、特に高級志向の顧客が多いエリアにおける競争環境を厳しくする。いかりスーパーの周辺店舗は、品揃えの独自性や、顧客体験のさらなる向上を通じて差別化を図る必要がある。</a:t>
+              <a:t>*   成城石井イオンモール堺北花田店の新規出店は、いかりスーパーが展開する大阪府内の店舗、特に郊外立地で高品質商品を求める顧客層に対して新たな選択肢を提供する。成城石井のブランド力と商品構成は、いかりスーパーと同様に「上質」「こだわり」を求める顧客層をターゲットとしており、品揃えの独自性やサービス強化による差別化が求められる。</a:t>
             </a:r>
           </a:p>
           <a:p>
@@ -4385,7 +4520,7 @@
               </a:defRPr>
             </a:pPr>
             <a:r>
-              <a:t>*   2027年春にオープン予定の「ヤマダストアー宝塚店」は、いかりスーパー宝塚店や周辺のいかり店舗にとって極めて大きな脅威となる。ヤマダストアーは「高品質・こだわり」を追求する点でいかりスーパーと類似しており、宝塚エリアにおける高級スーパー市場での直接的な顧客争奪戦が予想される。いかりスーパーは、地域に根ざした商品やサービス、コミュニティとの連携を一層強化し、顧客ロイヤルティを維持・向上させる戦略が求められる。</a:t>
+              <a:t>*   ヤマダストアー大阪梅田店の大丸梅田店地下への出店は、いかりJR大阪駅店およびいかり大丸梅田店（仮称）にとって直接的な脅威となる。ヤマダストアーも高品質・こだわり商品を展開しており、百貨店内の高級食品フロアという立地で、いかりスーパーと同様の顧客層をターゲットとするため、品揃えの独自性や、ギフト需要への対応、特別な顧客体験の提供など、一層の差別化戦略が求められる。</a:t>
             </a:r>
           </a:p>
           <a:p>
@@ -4400,7 +4535,22 @@
               </a:defRPr>
             </a:pPr>
             <a:r>
-              <a:t>*   オーケーの大阪府内での継続的な出店（高槻赤大路店、長吉店）は、価格に敏感な顧客層の取り込みを加速させ、広範囲でスーパーマーケット市場全体の競争を激化させる。いかりスーパーは、高品質・高価格帯というポジショニングを再確認し、価格以外の価値（品揃え、サービス、店舗体験など）を明確に訴求することで、競合との差別化を強化する必要がある。</a:t>
+              <a:t>*   阪急OASISマルシェ豊中駅前店のリニューアルは、いかりスーパー豊中店にとって競争激化の要因となる。阪急オアシスが「価値訴求型」と「価格訴求型」のハイブリッド型店舗を目指すことで、いかりスーパーの持つ高品質ブランドイメージと、日常使いの利便性を両立させようとする動きに対応するため、いかりスーパーは独自の顧客体験や地域密着型サービスをさらに強化し、顧客ロイヤルティを維持・向上させる必要がある。</a:t>
+            </a:r>
+          </a:p>
+          <a:p>
+            <a:pPr>
+              <a:spcAft>
+                <a:spcPts val="1200"/>
+              </a:spcAft>
+              <a:defRPr sz="1350">
+                <a:solidFill>
+                  <a:srgbClr val="1E1E1E"/>
+                </a:solidFill>
+              </a:defRPr>
+            </a:pPr>
+            <a:r>
+              <a:t>*   阪急オアシス服部西店および関西スーパー西郷店の臨時休業は短期間ではあるが、その間に周辺のいかりスーパー店舗への顧客の流動が生じる可能性がある。特に改装後の再オープンにおいては、いかりスーパーは改めて自店舗の魅力や強みを顧客に訴求し、流出した顧客の再獲得に努める必要がある。</a:t>
             </a:r>
           </a:p>
         </p:txBody>
@@ -4499,7 +4649,16 @@
                   <a:srgbClr val="1E1E1E"/>
                 </a:solidFill>
               </a:rPr>
-              <a:t>  オーケーnews｜4月5月で関西に4店舗を出店/計11店舗体制 流通スーパーニュース. (2026年4月16日).</a:t>
+              <a:t>  </a:t>
+            </a:r>
+            <a:r>
+              <a:rPr sz="1200" u="sng">
+                <a:solidFill>
+                  <a:srgbClr val="0066CC"/>
+                </a:solidFill>
+                <a:hlinkClick r:id="rId2"/>
+              </a:rPr>
+              <a:t>兵庫:「ヤマダストアー」大阪進出、大丸梅田店「デパ地下」に店舗では最大級の規模でオープン…生鮮食品・店内調理品も 読売新聞</a:t>
             </a:r>
           </a:p>
           <a:p>
@@ -4522,7 +4681,16 @@
                   <a:srgbClr val="1E1E1E"/>
                 </a:solidFill>
               </a:rPr>
-              <a:t>  オーケーが25年兵庫に出す5店を公表 26年には大阪に7店出店 激流オンライン. (2024年12月24日).</a:t>
+              <a:t>  </a:t>
+            </a:r>
+            <a:r>
+              <a:rPr sz="1200" u="sng">
+                <a:solidFill>
+                  <a:srgbClr val="0066CC"/>
+                </a:solidFill>
+                <a:hlinkClick r:id="rId3"/>
+              </a:rPr>
+              <a:t>【大阪に初出店】兵庫で人気のスーパー「ヤマダストアー」が梅田のデパ地下に登場 リビングWeb</a:t>
             </a:r>
           </a:p>
           <a:p>
@@ -4545,7 +4713,16 @@
                   <a:srgbClr val="1E1E1E"/>
                 </a:solidFill>
               </a:rPr>
-              <a:t>  オーケーnews｜'26年度関西7店舗出店､4/15南津守店､4/22今川店オープン. (2026年2月24日).</a:t>
+              <a:t>  </a:t>
+            </a:r>
+            <a:r>
+              <a:rPr sz="1200" u="sng">
+                <a:solidFill>
+                  <a:srgbClr val="0066CC"/>
+                </a:solidFill>
+                <a:hlinkClick r:id="rId4"/>
+              </a:rPr>
+              <a:t>ヤマダストアー Wikipedia</a:t>
             </a:r>
           </a:p>
           <a:p>
@@ -4568,7 +4745,16 @@
                   <a:srgbClr val="1E1E1E"/>
                 </a:solidFill>
               </a:rPr>
-              <a:t>  ディスカウント・スーパーマーケット「オーケー南津守店（関西8号店）」2026年4月15日(水)、 「オーケー今川店（関西9号店）」 2026年4月22日(水) 連続出店！ ～2026年は大阪府での展開を加速します！～. (2026年2月24日).</a:t>
+              <a:t>  </a:t>
+            </a:r>
+            <a:r>
+              <a:rPr sz="1200" u="sng">
+                <a:solidFill>
+                  <a:srgbClr val="0066CC"/>
+                </a:solidFill>
+                <a:hlinkClick r:id="rId5"/>
+              </a:rPr>
+              <a:t>6月26日（金）「阪急OASISマルシェ豊中駅前店」としてリニューアルオープン！ | エトレとよなか</a:t>
             </a:r>
           </a:p>
           <a:p>
@@ -4591,145 +4777,16 @@
                   <a:srgbClr val="1E1E1E"/>
                 </a:solidFill>
               </a:rPr>
-              <a:t>  オーケー／25年兵庫県5店舗、26年大阪府7店舗オープン \| 流通ニュース. (2024年12月23日).</a:t>
-            </a:r>
-          </a:p>
-          <a:p>
-            <a:pPr>
-              <a:spcAft>
-                <a:spcPts val="800"/>
-              </a:spcAft>
-            </a:pPr>
-            <a:r>
-              <a:rPr sz="1200">
-                <a:solidFill>
-                  <a:srgbClr val="1E1E1E"/>
-                </a:solidFill>
+              <a:t>  </a:t>
+            </a:r>
+            <a:r>
+              <a:rPr sz="1200" u="sng">
+                <a:solidFill>
+                  <a:srgbClr val="0066CC"/>
+                </a:solidFill>
+                <a:hlinkClick r:id="rId6"/>
               </a:rPr>
-              <a:t>・ </a:t>
-            </a:r>
-            <a:r>
-              <a:rPr sz="1200">
-                <a:solidFill>
-                  <a:srgbClr val="1E1E1E"/>
-                </a:solidFill>
-              </a:rPr>
-              <a:t>  ディスカウント・スーパーマーケット「オーケー」 大阪府での展開を加速！5月に「大東新田西町店」「豊中穂積店」を連続出店 ～2026年度は大阪府内に計7店舗の出店を予定. (2026年4月14日).</a:t>
-            </a:r>
-          </a:p>
-          <a:p>
-            <a:pPr>
-              <a:spcAft>
-                <a:spcPts val="800"/>
-              </a:spcAft>
-            </a:pPr>
-            <a:r>
-              <a:rPr sz="1200">
-                <a:solidFill>
-                  <a:srgbClr val="1E1E1E"/>
-                </a:solidFill>
-              </a:rPr>
-              <a:t>・ </a:t>
-            </a:r>
-            <a:r>
-              <a:rPr sz="1200">
-                <a:solidFill>
-                  <a:srgbClr val="1E1E1E"/>
-                </a:solidFill>
-              </a:rPr>
-              <a:t>  成城石井、大阪府堺市に「成城石井 イオンモール堺北花田店」6月18日オープン. (2026年6月17日).</a:t>
-            </a:r>
-          </a:p>
-          <a:p>
-            <a:pPr>
-              <a:spcAft>
-                <a:spcPts val="800"/>
-              </a:spcAft>
-            </a:pPr>
-            <a:r>
-              <a:rPr sz="1200">
-                <a:solidFill>
-                  <a:srgbClr val="1E1E1E"/>
-                </a:solidFill>
-              </a:rPr>
-              <a:t>・ </a:t>
-            </a:r>
-            <a:r>
-              <a:rPr sz="1200">
-                <a:solidFill>
-                  <a:srgbClr val="1E1E1E"/>
-                </a:solidFill>
-              </a:rPr>
-              <a:t>  関西地方 \| 出店ウォッチ. (2026年6月7日).</a:t>
-            </a:r>
-          </a:p>
-          <a:p>
-            <a:pPr>
-              <a:spcAft>
-                <a:spcPts val="800"/>
-              </a:spcAft>
-            </a:pPr>
-            <a:r>
-              <a:rPr sz="1200">
-                <a:solidFill>
-                  <a:srgbClr val="1E1E1E"/>
-                </a:solidFill>
-              </a:rPr>
-              <a:t>・ </a:t>
-            </a:r>
-            <a:r>
-              <a:rPr sz="1200">
-                <a:solidFill>
-                  <a:srgbClr val="1E1E1E"/>
-                </a:solidFill>
-              </a:rPr>
-              <a:t>  成城石井 イオンモール堺北花田店｣6/18オープン 流通スーパーニュース. (2026年6月11日).</a:t>
-            </a:r>
-          </a:p>
-          <a:p>
-            <a:pPr>
-              <a:spcAft>
-                <a:spcPts val="800"/>
-              </a:spcAft>
-            </a:pPr>
-            <a:r>
-              <a:rPr sz="1200">
-                <a:solidFill>
-                  <a:srgbClr val="1E1E1E"/>
-                </a:solidFill>
-              </a:rPr>
-              <a:t>・ </a:t>
-            </a:r>
-            <a:r>
-              <a:rPr sz="1200">
-                <a:solidFill>
-                  <a:srgbClr val="1E1E1E"/>
-                </a:solidFill>
-              </a:rPr>
-              <a:t>  成城石井イオンモール堺北花田店、2026年6月18日開店－郊外型店舗の強化進める成城石井、さらなる狭小店展開 \| 都市商業研究所. (2026年6月17日).</a:t>
-            </a:r>
-          </a:p>
-          <a:p>
-            <a:pPr>
-              <a:spcAft>
-                <a:spcPts val="800"/>
-              </a:spcAft>
-            </a:pPr>
-            <a:r>
-              <a:rPr sz="1200">
-                <a:solidFill>
-                  <a:srgbClr val="1E1E1E"/>
-                </a:solidFill>
-              </a:rPr>
-              <a:t>・ </a:t>
-            </a:r>
-            <a:r>
-              <a:rPr sz="1200">
-                <a:solidFill>
-                  <a:srgbClr val="1E1E1E"/>
-                </a:solidFill>
-              </a:rPr>
-              <a:t>  【堺市】「成城石井 イオンモール堺北花田店」が6月18日にオープン 御堂筋線・北花田駅至近のイオンモール1階に出店. (2026年6月15日).</a:t>
+              <a:t>成城石井、大阪府堺市に「成城石井 イオンモール堺北花田店」6月18日オープン</a:t>
             </a:r>
           </a:p>
         </p:txBody>

</xml_diff>

<commit_message>
fix: correctly skip table alignment separator row in markdown parser and frontend
</commit_message>
<xml_diff>
--- a/report/2026_06_18_competitive_report.pptx
+++ b/report/2026_06_18_competitive_report.pptx
@@ -3382,7 +3382,7 @@
                 <a:gridCol w="1371600"/>
                 <a:gridCol w="4416552"/>
               </a:tblGrid>
-              <a:tr h="679268">
+              <a:tr h="792480">
                 <a:tc>
                   <a:txBody>
                     <a:bodyPr/>
@@ -3522,7 +3522,7 @@
                   </a:tcPr>
                 </a:tc>
               </a:tr>
-              <a:tr h="679268">
+              <a:tr h="792480">
                 <a:tc>
                   <a:txBody>
                     <a:bodyPr/>
@@ -3536,7 +3536,7 @@
                         </a:defRPr>
                       </a:pPr>
                       <a:r>
-                        <a:t>:---</a:t>
+                        <a:t>大阪府堺市北区</a:t>
                       </a:r>
                     </a:p>
                   </a:txBody>
@@ -3559,7 +3559,7 @@
                         </a:defRPr>
                       </a:pPr>
                       <a:r>
-                        <a:t>:---</a:t>
+                        <a:t>成城石井 イオンモール堺北花田店</a:t>
                       </a:r>
                     </a:p>
                   </a:txBody>
@@ -3582,263 +3582,7 @@
                         </a:defRPr>
                       </a:pPr>
                       <a:r>
-                        <a:t>:---</a:t>
-                      </a:r>
-                    </a:p>
-                  </a:txBody>
-                  <a:tcPr>
-                    <a:solidFill>
-                      <a:srgbClr val="F5F5F5"/>
-                    </a:solidFill>
-                  </a:tcPr>
-                </a:tc>
-                <a:tc>
-                  <a:txBody>
-                    <a:bodyPr/>
-                    <a:lstStyle/>
-                    <a:p>
-                      <a:pPr>
-                        <a:defRPr sz="950">
-                          <a:solidFill>
-                            <a:srgbClr val="1E1E1E"/>
-                          </a:solidFill>
-                        </a:defRPr>
-                      </a:pPr>
-                      <a:r>
-                        <a:t>:---</a:t>
-                      </a:r>
-                    </a:p>
-                  </a:txBody>
-                  <a:tcPr>
-                    <a:solidFill>
-                      <a:srgbClr val="F5F5F5"/>
-                    </a:solidFill>
-                  </a:tcPr>
-                </a:tc>
-                <a:tc>
-                  <a:txBody>
-                    <a:bodyPr/>
-                    <a:lstStyle/>
-                    <a:p>
-                      <a:pPr>
-                        <a:defRPr sz="950">
-                          <a:solidFill>
-                            <a:srgbClr val="1E1E1E"/>
-                          </a:solidFill>
-                        </a:defRPr>
-                      </a:pPr>
-                      <a:r>
-                        <a:t>:---</a:t>
-                      </a:r>
-                    </a:p>
-                  </a:txBody>
-                  <a:tcPr>
-                    <a:solidFill>
-                      <a:srgbClr val="F5F5F5"/>
-                    </a:solidFill>
-                  </a:tcPr>
-                </a:tc>
-                <a:tc>
-                  <a:txBody>
-                    <a:bodyPr/>
-                    <a:lstStyle/>
-                    <a:p>
-                      <a:pPr>
-                        <a:defRPr sz="950">
-                          <a:solidFill>
-                            <a:srgbClr val="1E1E1E"/>
-                          </a:solidFill>
-                        </a:defRPr>
-                      </a:pPr>
-                      <a:r>
-                        <a:t>:---</a:t>
-                      </a:r>
-                    </a:p>
-                  </a:txBody>
-                  <a:tcPr>
-                    <a:solidFill>
-                      <a:srgbClr val="F5F5F5"/>
-                    </a:solidFill>
-                  </a:tcPr>
-                </a:tc>
-              </a:tr>
-              <a:tr h="679268">
-                <a:tc>
-                  <a:txBody>
-                    <a:bodyPr/>
-                    <a:lstStyle/>
-                    <a:p>
-                      <a:pPr>
-                        <a:defRPr sz="950">
-                          <a:solidFill>
-                            <a:srgbClr val="1E1E1E"/>
-                          </a:solidFill>
-                        </a:defRPr>
-                      </a:pPr>
-                      <a:r>
-                        <a:t>大阪府堺市北区</a:t>
-                      </a:r>
-                    </a:p>
-                  </a:txBody>
-                  <a:tcPr/>
-                </a:tc>
-                <a:tc>
-                  <a:txBody>
-                    <a:bodyPr/>
-                    <a:lstStyle/>
-                    <a:p>
-                      <a:pPr>
-                        <a:defRPr sz="950">
-                          <a:solidFill>
-                            <a:srgbClr val="1E1E1E"/>
-                          </a:solidFill>
-                        </a:defRPr>
-                      </a:pPr>
-                      <a:r>
-                        <a:t>成城石井 イオンモール堺北花田店</a:t>
-                      </a:r>
-                    </a:p>
-                  </a:txBody>
-                  <a:tcPr/>
-                </a:tc>
-                <a:tc>
-                  <a:txBody>
-                    <a:bodyPr/>
-                    <a:lstStyle/>
-                    <a:p>
-                      <a:pPr>
-                        <a:defRPr sz="950">
-                          <a:solidFill>
-                            <a:srgbClr val="1E1E1E"/>
-                          </a:solidFill>
-                        </a:defRPr>
-                      </a:pPr>
-                      <a:r>
                         <a:t>2026年6月18日</a:t>
-                      </a:r>
-                    </a:p>
-                  </a:txBody>
-                  <a:tcPr/>
-                </a:tc>
-                <a:tc>
-                  <a:txBody>
-                    <a:bodyPr/>
-                    <a:lstStyle/>
-                    <a:p>
-                      <a:pPr>
-                        <a:defRPr sz="950">
-                          <a:solidFill>
-                            <a:srgbClr val="1E1E1E"/>
-                          </a:solidFill>
-                        </a:defRPr>
-                      </a:pPr>
-                      <a:r>
-                        <a:t>新規出店</a:t>
-                      </a:r>
-                    </a:p>
-                  </a:txBody>
-                  <a:tcPr/>
-                </a:tc>
-                <a:tc>
-                  <a:txBody>
-                    <a:bodyPr/>
-                    <a:lstStyle/>
-                    <a:p>
-                      <a:pPr>
-                        <a:defRPr sz="950">
-                          <a:solidFill>
-                            <a:srgbClr val="1E1E1E"/>
-                          </a:solidFill>
-                        </a:defRPr>
-                      </a:pPr>
-                      <a:r>
-                        <a:t>中</a:t>
-                      </a:r>
-                    </a:p>
-                  </a:txBody>
-                  <a:tcPr/>
-                </a:tc>
-                <a:tc>
-                  <a:txBody>
-                    <a:bodyPr/>
-                    <a:lstStyle/>
-                    <a:p>
-                      <a:pPr>
-                        <a:defRPr sz="950">
-                          <a:solidFill>
-                            <a:srgbClr val="1E1E1E"/>
-                          </a:solidFill>
-                        </a:defRPr>
-                      </a:pPr>
-                      <a:r>
-                        <a:t>Osaka Metro御堂筋線「北花田駅」近くのショッピングセンター「イオンモール堺北花田」1階にオープン。売場面積は約38坪で、惣菜やデザート、パン、グロサリー、酒類など幅広い商品を取りそろえる。</a:t>
-                      </a:r>
-                    </a:p>
-                  </a:txBody>
-                  <a:tcPr/>
-                </a:tc>
-              </a:tr>
-              <a:tr h="679268">
-                <a:tc>
-                  <a:txBody>
-                    <a:bodyPr/>
-                    <a:lstStyle/>
-                    <a:p>
-                      <a:pPr>
-                        <a:defRPr sz="950">
-                          <a:solidFill>
-                            <a:srgbClr val="1E1E1E"/>
-                          </a:solidFill>
-                        </a:defRPr>
-                      </a:pPr>
-                      <a:r>
-                        <a:t>大阪府大阪市北区</a:t>
-                      </a:r>
-                    </a:p>
-                  </a:txBody>
-                  <a:tcPr>
-                    <a:solidFill>
-                      <a:srgbClr val="F5F5F5"/>
-                    </a:solidFill>
-                  </a:tcPr>
-                </a:tc>
-                <a:tc>
-                  <a:txBody>
-                    <a:bodyPr/>
-                    <a:lstStyle/>
-                    <a:p>
-                      <a:pPr>
-                        <a:defRPr sz="950">
-                          <a:solidFill>
-                            <a:srgbClr val="1E1E1E"/>
-                          </a:solidFill>
-                        </a:defRPr>
-                      </a:pPr>
-                      <a:r>
-                        <a:t>ヤマダストアー 大阪梅田店（大丸梅田店B2階）</a:t>
-                      </a:r>
-                    </a:p>
-                  </a:txBody>
-                  <a:tcPr>
-                    <a:solidFill>
-                      <a:srgbClr val="F5F5F5"/>
-                    </a:solidFill>
-                  </a:tcPr>
-                </a:tc>
-                <a:tc>
-                  <a:txBody>
-                    <a:bodyPr/>
-                    <a:lstStyle/>
-                    <a:p>
-                      <a:pPr>
-                        <a:defRPr sz="950">
-                          <a:solidFill>
-                            <a:srgbClr val="1E1E1E"/>
-                          </a:solidFill>
-                        </a:defRPr>
-                      </a:pPr>
-                      <a:r>
-                        <a:t>2026年冬</a:t>
                       </a:r>
                     </a:p>
                   </a:txBody>
@@ -3884,7 +3628,7 @@
                         </a:defRPr>
                       </a:pPr>
                       <a:r>
-                        <a:t>高</a:t>
+                        <a:t>中</a:t>
                       </a:r>
                     </a:p>
                   </a:txBody>
@@ -3907,7 +3651,7 @@
                         </a:defRPr>
                       </a:pPr>
                       <a:r>
-                        <a:t>兵庫県を中心に高品質・こだわり商品を展開するヤマダストアーが、JR大阪駅直結の大丸梅田店の地下食品フロアにオープン予定。</a:t>
+                        <a:t>Osaka Metro御堂筋線「北花田駅」近くのショッピングセンター「イオンモール堺北花田」1階にオープン。売場面積は約38坪で、惣菜やデザート、パン、グロサリー、酒類など幅広い商品を取りそろえる。</a:t>
                       </a:r>
                     </a:p>
                   </a:txBody>
@@ -3918,7 +3662,7 @@
                   </a:tcPr>
                 </a:tc>
               </a:tr>
-              <a:tr h="679268">
+              <a:tr h="792480">
                 <a:tc>
                   <a:txBody>
                     <a:bodyPr/>
@@ -3932,7 +3676,7 @@
                         </a:defRPr>
                       </a:pPr>
                       <a:r>
-                        <a:t>大阪府豊中市</a:t>
+                        <a:t>大阪府大阪市北区</a:t>
                       </a:r>
                     </a:p>
                   </a:txBody>
@@ -3951,7 +3695,7 @@
                         </a:defRPr>
                       </a:pPr>
                       <a:r>
-                        <a:t>阪急OASISマルシェ豊中駅前店</a:t>
+                        <a:t>ヤマダストアー 大阪梅田店（大丸梅田店B2階）</a:t>
                       </a:r>
                     </a:p>
                   </a:txBody>
@@ -3970,7 +3714,7 @@
                         </a:defRPr>
                       </a:pPr>
                       <a:r>
-                        <a:t>2026年6月26日</a:t>
+                        <a:t>2026年冬</a:t>
                       </a:r>
                     </a:p>
                   </a:txBody>
@@ -3989,7 +3733,7 @@
                         </a:defRPr>
                       </a:pPr>
                       <a:r>
-                        <a:t>リニューアルオープン</a:t>
+                        <a:t>新規出店</a:t>
                       </a:r>
                     </a:p>
                   </a:txBody>
@@ -4008,7 +3752,7 @@
                         </a:defRPr>
                       </a:pPr>
                       <a:r>
-                        <a:t>中</a:t>
+                        <a:t>高</a:t>
                       </a:r>
                     </a:p>
                   </a:txBody>
@@ -4027,14 +3771,14 @@
                         </a:defRPr>
                       </a:pPr>
                       <a:r>
-                        <a:t>阪急オアシス豊中駅前店が6月15日18時に一時休業し、6月26日に「価値訴求型」と「価格訴求型」を融合した「阪急OASISマルシェ豊中駅前店」としてリニューアルオープンする。</a:t>
+                        <a:t>兵庫県を中心に高品質・こだわり商品を展開するヤマダストアーが、JR大阪駅直結の大丸梅田店の地下食品フロアにオープン予定。</a:t>
                       </a:r>
                     </a:p>
                   </a:txBody>
                   <a:tcPr/>
                 </a:tc>
               </a:tr>
-              <a:tr h="679268">
+              <a:tr h="792480">
                 <a:tc>
                   <a:txBody>
                     <a:bodyPr/>
@@ -4071,7 +3815,7 @@
                         </a:defRPr>
                       </a:pPr>
                       <a:r>
-                        <a:t>阪急オアシス 服部西店</a:t>
+                        <a:t>阪急OASISマルシェ豊中駅前店</a:t>
                       </a:r>
                     </a:p>
                   </a:txBody>
@@ -4094,7 +3838,7 @@
                         </a:defRPr>
                       </a:pPr>
                       <a:r>
-                        <a:t>2026年7月7日～7月16日</a:t>
+                        <a:t>2026年6月26日</a:t>
                       </a:r>
                     </a:p>
                   </a:txBody>
@@ -4117,7 +3861,263 @@
                         </a:defRPr>
                       </a:pPr>
                       <a:r>
+                        <a:t>リニューアルオープン</a:t>
+                      </a:r>
+                    </a:p>
+                  </a:txBody>
+                  <a:tcPr>
+                    <a:solidFill>
+                      <a:srgbClr val="F5F5F5"/>
+                    </a:solidFill>
+                  </a:tcPr>
+                </a:tc>
+                <a:tc>
+                  <a:txBody>
+                    <a:bodyPr/>
+                    <a:lstStyle/>
+                    <a:p>
+                      <a:pPr>
+                        <a:defRPr sz="950">
+                          <a:solidFill>
+                            <a:srgbClr val="1E1E1E"/>
+                          </a:solidFill>
+                        </a:defRPr>
+                      </a:pPr>
+                      <a:r>
+                        <a:t>中</a:t>
+                      </a:r>
+                    </a:p>
+                  </a:txBody>
+                  <a:tcPr>
+                    <a:solidFill>
+                      <a:srgbClr val="F5F5F5"/>
+                    </a:solidFill>
+                  </a:tcPr>
+                </a:tc>
+                <a:tc>
+                  <a:txBody>
+                    <a:bodyPr/>
+                    <a:lstStyle/>
+                    <a:p>
+                      <a:pPr>
+                        <a:defRPr sz="950">
+                          <a:solidFill>
+                            <a:srgbClr val="1E1E1E"/>
+                          </a:solidFill>
+                        </a:defRPr>
+                      </a:pPr>
+                      <a:r>
+                        <a:t>阪急オアシス豊中駅前店が6月15日18時に一時休業し、6月26日に「価値訴求型」と「価格訴求型」を融合した「阪急OASISマルシェ豊中駅前店」としてリニューアルオープンする。</a:t>
+                      </a:r>
+                    </a:p>
+                  </a:txBody>
+                  <a:tcPr>
+                    <a:solidFill>
+                      <a:srgbClr val="F5F5F5"/>
+                    </a:solidFill>
+                  </a:tcPr>
+                </a:tc>
+              </a:tr>
+              <a:tr h="792480">
+                <a:tc>
+                  <a:txBody>
+                    <a:bodyPr/>
+                    <a:lstStyle/>
+                    <a:p>
+                      <a:pPr>
+                        <a:defRPr sz="950">
+                          <a:solidFill>
+                            <a:srgbClr val="1E1E1E"/>
+                          </a:solidFill>
+                        </a:defRPr>
+                      </a:pPr>
+                      <a:r>
+                        <a:t>大阪府豊中市</a:t>
+                      </a:r>
+                    </a:p>
+                  </a:txBody>
+                  <a:tcPr/>
+                </a:tc>
+                <a:tc>
+                  <a:txBody>
+                    <a:bodyPr/>
+                    <a:lstStyle/>
+                    <a:p>
+                      <a:pPr>
+                        <a:defRPr sz="950">
+                          <a:solidFill>
+                            <a:srgbClr val="1E1E1E"/>
+                          </a:solidFill>
+                        </a:defRPr>
+                      </a:pPr>
+                      <a:r>
+                        <a:t>阪急オアシス 服部西店</a:t>
+                      </a:r>
+                    </a:p>
+                  </a:txBody>
+                  <a:tcPr/>
+                </a:tc>
+                <a:tc>
+                  <a:txBody>
+                    <a:bodyPr/>
+                    <a:lstStyle/>
+                    <a:p>
+                      <a:pPr>
+                        <a:defRPr sz="950">
+                          <a:solidFill>
+                            <a:srgbClr val="1E1E1E"/>
+                          </a:solidFill>
+                        </a:defRPr>
+                      </a:pPr>
+                      <a:r>
+                        <a:t>2026年7月7日～7月16日</a:t>
+                      </a:r>
+                    </a:p>
+                  </a:txBody>
+                  <a:tcPr/>
+                </a:tc>
+                <a:tc>
+                  <a:txBody>
+                    <a:bodyPr/>
+                    <a:lstStyle/>
+                    <a:p>
+                      <a:pPr>
+                        <a:defRPr sz="950">
+                          <a:solidFill>
+                            <a:srgbClr val="1E1E1E"/>
+                          </a:solidFill>
+                        </a:defRPr>
+                      </a:pPr>
+                      <a:r>
                         <a:t>臨時休業（改装の可能性あり）</a:t>
+                      </a:r>
+                    </a:p>
+                  </a:txBody>
+                  <a:tcPr/>
+                </a:tc>
+                <a:tc>
+                  <a:txBody>
+                    <a:bodyPr/>
+                    <a:lstStyle/>
+                    <a:p>
+                      <a:pPr>
+                        <a:defRPr sz="950">
+                          <a:solidFill>
+                            <a:srgbClr val="1E1E1E"/>
+                          </a:solidFill>
+                        </a:defRPr>
+                      </a:pPr>
+                      <a:r>
+                        <a:t>低</a:t>
+                      </a:r>
+                    </a:p>
+                  </a:txBody>
+                  <a:tcPr/>
+                </a:tc>
+                <a:tc>
+                  <a:txBody>
+                    <a:bodyPr/>
+                    <a:lstStyle/>
+                    <a:p>
+                      <a:pPr>
+                        <a:defRPr sz="950">
+                          <a:solidFill>
+                            <a:srgbClr val="1E1E1E"/>
+                          </a:solidFill>
+                        </a:defRPr>
+                      </a:pPr>
+                      <a:r>
+                        <a:t>阪急オアシス服部西店が設備点検・改装のため臨時休業予定。</a:t>
+                      </a:r>
+                    </a:p>
+                  </a:txBody>
+                  <a:tcPr/>
+                </a:tc>
+              </a:tr>
+              <a:tr h="792480">
+                <a:tc>
+                  <a:txBody>
+                    <a:bodyPr/>
+                    <a:lstStyle/>
+                    <a:p>
+                      <a:pPr>
+                        <a:defRPr sz="950">
+                          <a:solidFill>
+                            <a:srgbClr val="1E1E1E"/>
+                          </a:solidFill>
+                        </a:defRPr>
+                      </a:pPr>
+                      <a:r>
+                        <a:t>兵庫県神戸市灘区</a:t>
+                      </a:r>
+                    </a:p>
+                  </a:txBody>
+                  <a:tcPr>
+                    <a:solidFill>
+                      <a:srgbClr val="F5F5F5"/>
+                    </a:solidFill>
+                  </a:tcPr>
+                </a:tc>
+                <a:tc>
+                  <a:txBody>
+                    <a:bodyPr/>
+                    <a:lstStyle/>
+                    <a:p>
+                      <a:pPr>
+                        <a:defRPr sz="950">
+                          <a:solidFill>
+                            <a:srgbClr val="1E1E1E"/>
+                          </a:solidFill>
+                        </a:defRPr>
+                      </a:pPr>
+                      <a:r>
+                        <a:t>関西スーパー 西郷店</a:t>
+                      </a:r>
+                    </a:p>
+                  </a:txBody>
+                  <a:tcPr>
+                    <a:solidFill>
+                      <a:srgbClr val="F5F5F5"/>
+                    </a:solidFill>
+                  </a:tcPr>
+                </a:tc>
+                <a:tc>
+                  <a:txBody>
+                    <a:bodyPr/>
+                    <a:lstStyle/>
+                    <a:p>
+                      <a:pPr>
+                        <a:defRPr sz="950">
+                          <a:solidFill>
+                            <a:srgbClr val="1E1E1E"/>
+                          </a:solidFill>
+                        </a:defRPr>
+                      </a:pPr>
+                      <a:r>
+                        <a:t>2026年6月30日～7月2日</a:t>
+                      </a:r>
+                    </a:p>
+                  </a:txBody>
+                  <a:tcPr>
+                    <a:solidFill>
+                      <a:srgbClr val="F5F5F5"/>
+                    </a:solidFill>
+                  </a:tcPr>
+                </a:tc>
+                <a:tc>
+                  <a:txBody>
+                    <a:bodyPr/>
+                    <a:lstStyle/>
+                    <a:p>
+                      <a:pPr>
+                        <a:defRPr sz="950">
+                          <a:solidFill>
+                            <a:srgbClr val="1E1E1E"/>
+                          </a:solidFill>
+                        </a:defRPr>
+                      </a:pPr>
+                      <a:r>
+                        <a:t>臨時休業</a:t>
                       </a:r>
                     </a:p>
                   </a:txBody>
@@ -4149,126 +4149,6 @@
                       <a:srgbClr val="F5F5F5"/>
                     </a:solidFill>
                   </a:tcPr>
-                </a:tc>
-                <a:tc>
-                  <a:txBody>
-                    <a:bodyPr/>
-                    <a:lstStyle/>
-                    <a:p>
-                      <a:pPr>
-                        <a:defRPr sz="950">
-                          <a:solidFill>
-                            <a:srgbClr val="1E1E1E"/>
-                          </a:solidFill>
-                        </a:defRPr>
-                      </a:pPr>
-                      <a:r>
-                        <a:t>阪急オアシス服部西店が設備点検・改装のため臨時休業予定。</a:t>
-                      </a:r>
-                    </a:p>
-                  </a:txBody>
-                  <a:tcPr>
-                    <a:solidFill>
-                      <a:srgbClr val="F5F5F5"/>
-                    </a:solidFill>
-                  </a:tcPr>
-                </a:tc>
-              </a:tr>
-              <a:tr h="679272">
-                <a:tc>
-                  <a:txBody>
-                    <a:bodyPr/>
-                    <a:lstStyle/>
-                    <a:p>
-                      <a:pPr>
-                        <a:defRPr sz="950">
-                          <a:solidFill>
-                            <a:srgbClr val="1E1E1E"/>
-                          </a:solidFill>
-                        </a:defRPr>
-                      </a:pPr>
-                      <a:r>
-                        <a:t>兵庫県神戸市灘区</a:t>
-                      </a:r>
-                    </a:p>
-                  </a:txBody>
-                  <a:tcPr/>
-                </a:tc>
-                <a:tc>
-                  <a:txBody>
-                    <a:bodyPr/>
-                    <a:lstStyle/>
-                    <a:p>
-                      <a:pPr>
-                        <a:defRPr sz="950">
-                          <a:solidFill>
-                            <a:srgbClr val="1E1E1E"/>
-                          </a:solidFill>
-                        </a:defRPr>
-                      </a:pPr>
-                      <a:r>
-                        <a:t>関西スーパー 西郷店</a:t>
-                      </a:r>
-                    </a:p>
-                  </a:txBody>
-                  <a:tcPr/>
-                </a:tc>
-                <a:tc>
-                  <a:txBody>
-                    <a:bodyPr/>
-                    <a:lstStyle/>
-                    <a:p>
-                      <a:pPr>
-                        <a:defRPr sz="950">
-                          <a:solidFill>
-                            <a:srgbClr val="1E1E1E"/>
-                          </a:solidFill>
-                        </a:defRPr>
-                      </a:pPr>
-                      <a:r>
-                        <a:t>2026年6月30日～7月2日</a:t>
-                      </a:r>
-                    </a:p>
-                  </a:txBody>
-                  <a:tcPr/>
-                </a:tc>
-                <a:tc>
-                  <a:txBody>
-                    <a:bodyPr/>
-                    <a:lstStyle/>
-                    <a:p>
-                      <a:pPr>
-                        <a:defRPr sz="950">
-                          <a:solidFill>
-                            <a:srgbClr val="1E1E1E"/>
-                          </a:solidFill>
-                        </a:defRPr>
-                      </a:pPr>
-                      <a:r>
-                        <a:t>臨時休業</a:t>
-                      </a:r>
-                    </a:p>
-                  </a:txBody>
-                  <a:tcPr/>
-                </a:tc>
-                <a:tc>
-                  <a:txBody>
-                    <a:bodyPr/>
-                    <a:lstStyle/>
-                    <a:p>
-                      <a:pPr>
-                        <a:defRPr sz="950">
-                          <a:solidFill>
-                            <a:srgbClr val="1E1E1E"/>
-                          </a:solidFill>
-                        </a:defRPr>
-                      </a:pPr>
-                      <a:r>
-                        <a:t>低</a:t>
-                      </a:r>
-                    </a:p>
-                  </a:txBody>
-                  <a:tcPr/>
                 </a:tc>
                 <a:tc>
                   <a:txBody>

</xml_diff>

<commit_message>
feat: enforce 2km radius constraint from existing ikari stores during report generation
</commit_message>
<xml_diff>
--- a/report/2026_06_18_competitive_report.pptx
+++ b/report/2026_06_18_competitive_report.pptx
@@ -3238,7 +3238,7 @@
               </a:defRPr>
             </a:pPr>
             <a:r>
-              <a:t>・   高級スーパーマーケットの競合環境において、いかりスーパーの顧客層と重複する可能性のあるエリアで、成城石井の新規出店が判明した。</a:t>
+              <a:t>・   2026年7月6日、いかりスーパーマーケットが大阪メトロ淀屋橋駅直結の「淀屋橋ステーションワン店」を新規オープンし、大阪都心部における自社店舗網を強化します。</a:t>
             </a:r>
           </a:p>
           <a:p>
@@ -3253,7 +3253,7 @@
               </a:defRPr>
             </a:pPr>
             <a:r>
-              <a:t>・   成城石井は2026年6月18日に大阪府堺市にイオンモール堺北花田店をオープンし、いかりスーパーの既存店舗と競合する可能性がある。</a:t>
+              <a:t>・   ヤマダストアーが2026年今冬に「大丸梅田店」地下2階に大阪初出店を予定しており、いかりJR大阪店と競合する高級スーパー市場での競争が激化します。</a:t>
             </a:r>
           </a:p>
           <a:p>
@@ -3268,37 +3268,7 @@
               </a:defRPr>
             </a:pPr>
             <a:r>
-              <a:t>・   ヤマダストアーは2026年冬に大阪梅田の大丸梅田店地下に新規出店を予定しており、都市部の高品質スーパー市場での競争が引き続き激化する見込みである。</a:t>
-            </a:r>
-          </a:p>
-          <a:p>
-            <a:pPr>
-              <a:spcAft>
-                <a:spcPts val="1600"/>
-              </a:spcAft>
-              <a:defRPr sz="1800">
-                <a:solidFill>
-                  <a:srgbClr val="1E1E1E"/>
-                </a:solidFill>
-              </a:defRPr>
-            </a:pPr>
-            <a:r>
-              <a:t>・   阪急オアシスは豊中駅前店を2026年6月26日に「阪急OASISマルシェ豊中駅前店」としてリニューアルオープンするほか、服部西店が2026年7月7日から臨時休業（改装の可能性あり）を予定しており、これらリニューアル店舗が地域での競争力を高める可能性がある。</a:t>
-            </a:r>
-          </a:p>
-          <a:p>
-            <a:pPr>
-              <a:spcAft>
-                <a:spcPts val="1600"/>
-              </a:spcAft>
-              <a:defRPr sz="1800">
-                <a:solidFill>
-                  <a:srgbClr val="1E1E1E"/>
-                </a:solidFill>
-              </a:defRPr>
-            </a:pPr>
-            <a:r>
-              <a:t>・   関西スーパー西郷店が2026年6月30日から臨時休業を予定しており、短期間ながら周辺エリアの顧客流動に影響を与える可能性がある。</a:t>
+              <a:t>・   ヤマダストアーは2027年春、いかり阪急逆瀬川店近隣の宝塚市伊孑志4丁目に新店舗を開業予定であり、宝塚エリアでも競合が本格化する見込みです。</a:t>
             </a:r>
           </a:p>
         </p:txBody>
@@ -3382,7 +3352,7 @@
                 <a:gridCol w="1371600"/>
                 <a:gridCol w="4416552"/>
               </a:tblGrid>
-              <a:tr h="792480">
+              <a:tr h="1188720">
                 <a:tc>
                   <a:txBody>
                     <a:bodyPr/>
@@ -3522,7 +3492,7 @@
                   </a:tcPr>
                 </a:tc>
               </a:tr>
-              <a:tr h="792480">
+              <a:tr h="1188720">
                 <a:tc>
                   <a:txBody>
                     <a:bodyPr/>
@@ -3536,7 +3506,7 @@
                         </a:defRPr>
                       </a:pPr>
                       <a:r>
-                        <a:t>大阪府堺市北区</a:t>
+                        <a:t>大阪市中央区（淀屋橋）</a:t>
                       </a:r>
                     </a:p>
                   </a:txBody>
@@ -3559,7 +3529,7 @@
                         </a:defRPr>
                       </a:pPr>
                       <a:r>
-                        <a:t>成城石井 イオンモール堺北花田店</a:t>
+                        <a:t>いかりスーパーマーケット 淀屋橋ステーションワン店</a:t>
                       </a:r>
                     </a:p>
                   </a:txBody>
@@ -3582,7 +3552,7 @@
                         </a:defRPr>
                       </a:pPr>
                       <a:r>
-                        <a:t>2026年6月18日</a:t>
+                        <a:t>2026年7月6日（月）</a:t>
                       </a:r>
                     </a:p>
                   </a:txBody>
@@ -3605,7 +3575,263 @@
                         </a:defRPr>
                       </a:pPr>
                       <a:r>
-                        <a:t>新規出店</a:t>
+                        <a:t>新規オープン</a:t>
+                      </a:r>
+                    </a:p>
+                  </a:txBody>
+                  <a:tcPr>
+                    <a:solidFill>
+                      <a:srgbClr val="F5F5F5"/>
+                    </a:solidFill>
+                  </a:tcPr>
+                </a:tc>
+                <a:tc>
+                  <a:txBody>
+                    <a:bodyPr/>
+                    <a:lstStyle/>
+                    <a:p>
+                      <a:pPr>
+                        <a:defRPr sz="950">
+                          <a:solidFill>
+                            <a:srgbClr val="1E1E1E"/>
+                          </a:solidFill>
+                        </a:defRPr>
+                      </a:pPr>
+                      <a:r>
+                        <a:t>内部強化（中）</a:t>
+                      </a:r>
+                    </a:p>
+                  </a:txBody>
+                  <a:tcPr>
+                    <a:solidFill>
+                      <a:srgbClr val="F5F5F5"/>
+                    </a:solidFill>
+                  </a:tcPr>
+                </a:tc>
+                <a:tc>
+                  <a:txBody>
+                    <a:bodyPr/>
+                    <a:lstStyle/>
+                    <a:p>
+                      <a:pPr>
+                        <a:defRPr sz="950">
+                          <a:solidFill>
+                            <a:srgbClr val="1E1E1E"/>
+                          </a:solidFill>
+                        </a:defRPr>
+                      </a:pPr>
+                      <a:r>
+                        <a:t>大阪メトロ淀屋橋駅・京阪淀屋橋駅直結の「淀屋橋ステーションワン」地下1階に、いかりスーパーマーケットの新店舗がオープン。いかりJR大阪店から約1.5km圏内で、ビジネス層や地域住民の利便性向上と、大阪都心部でのブランドプレゼンス強化を図ります。</a:t>
+                      </a:r>
+                    </a:p>
+                  </a:txBody>
+                  <a:tcPr>
+                    <a:solidFill>
+                      <a:srgbClr val="F5F5F5"/>
+                    </a:solidFill>
+                  </a:tcPr>
+                </a:tc>
+              </a:tr>
+              <a:tr h="1188720">
+                <a:tc>
+                  <a:txBody>
+                    <a:bodyPr/>
+                    <a:lstStyle/>
+                    <a:p>
+                      <a:pPr>
+                        <a:defRPr sz="950">
+                          <a:solidFill>
+                            <a:srgbClr val="1E1E1E"/>
+                          </a:solidFill>
+                        </a:defRPr>
+                      </a:pPr>
+                      <a:r>
+                        <a:t>大阪市北区（梅田）</a:t>
+                      </a:r>
+                    </a:p>
+                  </a:txBody>
+                  <a:tcPr/>
+                </a:tc>
+                <a:tc>
+                  <a:txBody>
+                    <a:bodyPr/>
+                    <a:lstStyle/>
+                    <a:p>
+                      <a:pPr>
+                        <a:defRPr sz="950">
+                          <a:solidFill>
+                            <a:srgbClr val="1E1E1E"/>
+                          </a:solidFill>
+                        </a:defRPr>
+                      </a:pPr>
+                      <a:r>
+                        <a:t>ヤマダストアー 大阪 梅田店</a:t>
+                      </a:r>
+                    </a:p>
+                  </a:txBody>
+                  <a:tcPr/>
+                </a:tc>
+                <a:tc>
+                  <a:txBody>
+                    <a:bodyPr/>
+                    <a:lstStyle/>
+                    <a:p>
+                      <a:pPr>
+                        <a:defRPr sz="950">
+                          <a:solidFill>
+                            <a:srgbClr val="1E1E1E"/>
+                          </a:solidFill>
+                        </a:defRPr>
+                      </a:pPr>
+                      <a:r>
+                        <a:t>2026年今冬（後半）</a:t>
+                      </a:r>
+                    </a:p>
+                  </a:txBody>
+                  <a:tcPr/>
+                </a:tc>
+                <a:tc>
+                  <a:txBody>
+                    <a:bodyPr/>
+                    <a:lstStyle/>
+                    <a:p>
+                      <a:pPr>
+                        <a:defRPr sz="950">
+                          <a:solidFill>
+                            <a:srgbClr val="1E1E1E"/>
+                          </a:solidFill>
+                        </a:defRPr>
+                      </a:pPr>
+                      <a:r>
+                        <a:t>新規オープン</a:t>
+                      </a:r>
+                    </a:p>
+                  </a:txBody>
+                  <a:tcPr/>
+                </a:tc>
+                <a:tc>
+                  <a:txBody>
+                    <a:bodyPr/>
+                    <a:lstStyle/>
+                    <a:p>
+                      <a:pPr>
+                        <a:defRPr sz="950">
+                          <a:solidFill>
+                            <a:srgbClr val="1E1E1E"/>
+                          </a:solidFill>
+                        </a:defRPr>
+                      </a:pPr>
+                      <a:r>
+                        <a:t>高</a:t>
+                      </a:r>
+                    </a:p>
+                  </a:txBody>
+                  <a:tcPr/>
+                </a:tc>
+                <a:tc>
+                  <a:txBody>
+                    <a:bodyPr/>
+                    <a:lstStyle/>
+                    <a:p>
+                      <a:pPr>
+                        <a:defRPr sz="950">
+                          <a:solidFill>
+                            <a:srgbClr val="1E1E1E"/>
+                          </a:solidFill>
+                        </a:defRPr>
+                      </a:pPr>
+                      <a:r>
+                        <a:t>兵庫県を拠点とする高品質スーパー「ヤマダストアー」が、大丸梅田店地下2階に大阪初出店。いかりJR大阪店と同一ビル内での開業となり、高級食材やこだわりの商品に強みを持つ両者間で直接的な競合が発生します。</a:t>
+                      </a:r>
+                    </a:p>
+                  </a:txBody>
+                  <a:tcPr/>
+                </a:tc>
+              </a:tr>
+              <a:tr h="1188720">
+                <a:tc>
+                  <a:txBody>
+                    <a:bodyPr/>
+                    <a:lstStyle/>
+                    <a:p>
+                      <a:pPr>
+                        <a:defRPr sz="950">
+                          <a:solidFill>
+                            <a:srgbClr val="1E1E1E"/>
+                          </a:solidFill>
+                        </a:defRPr>
+                      </a:pPr>
+                      <a:r>
+                        <a:t>兵庫県宝塚市（逆瀬川）</a:t>
+                      </a:r>
+                    </a:p>
+                  </a:txBody>
+                  <a:tcPr>
+                    <a:solidFill>
+                      <a:srgbClr val="F5F5F5"/>
+                    </a:solidFill>
+                  </a:tcPr>
+                </a:tc>
+                <a:tc>
+                  <a:txBody>
+                    <a:bodyPr/>
+                    <a:lstStyle/>
+                    <a:p>
+                      <a:pPr>
+                        <a:defRPr sz="950">
+                          <a:solidFill>
+                            <a:srgbClr val="1E1E1E"/>
+                          </a:solidFill>
+                        </a:defRPr>
+                      </a:pPr>
+                      <a:r>
+                        <a:t>ヤマダストアー宝塚店（仮称）</a:t>
+                      </a:r>
+                    </a:p>
+                  </a:txBody>
+                  <a:tcPr>
+                    <a:solidFill>
+                      <a:srgbClr val="F5F5F5"/>
+                    </a:solidFill>
+                  </a:tcPr>
+                </a:tc>
+                <a:tc>
+                  <a:txBody>
+                    <a:bodyPr/>
+                    <a:lstStyle/>
+                    <a:p>
+                      <a:pPr>
+                        <a:defRPr sz="950">
+                          <a:solidFill>
+                            <a:srgbClr val="1E1E1E"/>
+                          </a:solidFill>
+                        </a:defRPr>
+                      </a:pPr>
+                      <a:r>
+                        <a:t>2027年春</a:t>
+                      </a:r>
+                    </a:p>
+                  </a:txBody>
+                  <a:tcPr>
+                    <a:solidFill>
+                      <a:srgbClr val="F5F5F5"/>
+                    </a:solidFill>
+                  </a:tcPr>
+                </a:tc>
+                <a:tc>
+                  <a:txBody>
+                    <a:bodyPr/>
+                    <a:lstStyle/>
+                    <a:p>
+                      <a:pPr>
+                        <a:defRPr sz="950">
+                          <a:solidFill>
+                            <a:srgbClr val="1E1E1E"/>
+                          </a:solidFill>
+                        </a:defRPr>
+                      </a:pPr>
+                      <a:r>
+                        <a:t>新規オープン</a:t>
                       </a:r>
                     </a:p>
                   </a:txBody>
@@ -3651,7 +3877,7 @@
                         </a:defRPr>
                       </a:pPr>
                       <a:r>
-                        <a:t>Osaka Metro御堂筋線「北花田駅」近くのショッピングセンター「イオンモール堺北花田」1階にオープン。売場面積は約38坪で、惣菜やデザート、パン、グロサリー、酒類など幅広い商品を取りそろえる。</a:t>
+                        <a:t>兵庫県宝塚市伊孑志4丁目（阪急逆瀬川駅近く）に「ヤマダストアー宝塚店（仮称）」が開業予定。いかり阪急逆瀬川店から約0.5～1km圏内での出店となり、地域住民の取り合いが予想されます。</a:t>
                       </a:r>
                     </a:p>
                   </a:txBody>
@@ -3660,503 +3886,6 @@
                       <a:srgbClr val="F5F5F5"/>
                     </a:solidFill>
                   </a:tcPr>
-                </a:tc>
-              </a:tr>
-              <a:tr h="792480">
-                <a:tc>
-                  <a:txBody>
-                    <a:bodyPr/>
-                    <a:lstStyle/>
-                    <a:p>
-                      <a:pPr>
-                        <a:defRPr sz="950">
-                          <a:solidFill>
-                            <a:srgbClr val="1E1E1E"/>
-                          </a:solidFill>
-                        </a:defRPr>
-                      </a:pPr>
-                      <a:r>
-                        <a:t>大阪府大阪市北区</a:t>
-                      </a:r>
-                    </a:p>
-                  </a:txBody>
-                  <a:tcPr/>
-                </a:tc>
-                <a:tc>
-                  <a:txBody>
-                    <a:bodyPr/>
-                    <a:lstStyle/>
-                    <a:p>
-                      <a:pPr>
-                        <a:defRPr sz="950">
-                          <a:solidFill>
-                            <a:srgbClr val="1E1E1E"/>
-                          </a:solidFill>
-                        </a:defRPr>
-                      </a:pPr>
-                      <a:r>
-                        <a:t>ヤマダストアー 大阪梅田店（大丸梅田店B2階）</a:t>
-                      </a:r>
-                    </a:p>
-                  </a:txBody>
-                  <a:tcPr/>
-                </a:tc>
-                <a:tc>
-                  <a:txBody>
-                    <a:bodyPr/>
-                    <a:lstStyle/>
-                    <a:p>
-                      <a:pPr>
-                        <a:defRPr sz="950">
-                          <a:solidFill>
-                            <a:srgbClr val="1E1E1E"/>
-                          </a:solidFill>
-                        </a:defRPr>
-                      </a:pPr>
-                      <a:r>
-                        <a:t>2026年冬</a:t>
-                      </a:r>
-                    </a:p>
-                  </a:txBody>
-                  <a:tcPr/>
-                </a:tc>
-                <a:tc>
-                  <a:txBody>
-                    <a:bodyPr/>
-                    <a:lstStyle/>
-                    <a:p>
-                      <a:pPr>
-                        <a:defRPr sz="950">
-                          <a:solidFill>
-                            <a:srgbClr val="1E1E1E"/>
-                          </a:solidFill>
-                        </a:defRPr>
-                      </a:pPr>
-                      <a:r>
-                        <a:t>新規出店</a:t>
-                      </a:r>
-                    </a:p>
-                  </a:txBody>
-                  <a:tcPr/>
-                </a:tc>
-                <a:tc>
-                  <a:txBody>
-                    <a:bodyPr/>
-                    <a:lstStyle/>
-                    <a:p>
-                      <a:pPr>
-                        <a:defRPr sz="950">
-                          <a:solidFill>
-                            <a:srgbClr val="1E1E1E"/>
-                          </a:solidFill>
-                        </a:defRPr>
-                      </a:pPr>
-                      <a:r>
-                        <a:t>高</a:t>
-                      </a:r>
-                    </a:p>
-                  </a:txBody>
-                  <a:tcPr/>
-                </a:tc>
-                <a:tc>
-                  <a:txBody>
-                    <a:bodyPr/>
-                    <a:lstStyle/>
-                    <a:p>
-                      <a:pPr>
-                        <a:defRPr sz="950">
-                          <a:solidFill>
-                            <a:srgbClr val="1E1E1E"/>
-                          </a:solidFill>
-                        </a:defRPr>
-                      </a:pPr>
-                      <a:r>
-                        <a:t>兵庫県を中心に高品質・こだわり商品を展開するヤマダストアーが、JR大阪駅直結の大丸梅田店の地下食品フロアにオープン予定。</a:t>
-                      </a:r>
-                    </a:p>
-                  </a:txBody>
-                  <a:tcPr/>
-                </a:tc>
-              </a:tr>
-              <a:tr h="792480">
-                <a:tc>
-                  <a:txBody>
-                    <a:bodyPr/>
-                    <a:lstStyle/>
-                    <a:p>
-                      <a:pPr>
-                        <a:defRPr sz="950">
-                          <a:solidFill>
-                            <a:srgbClr val="1E1E1E"/>
-                          </a:solidFill>
-                        </a:defRPr>
-                      </a:pPr>
-                      <a:r>
-                        <a:t>大阪府豊中市</a:t>
-                      </a:r>
-                    </a:p>
-                  </a:txBody>
-                  <a:tcPr>
-                    <a:solidFill>
-                      <a:srgbClr val="F5F5F5"/>
-                    </a:solidFill>
-                  </a:tcPr>
-                </a:tc>
-                <a:tc>
-                  <a:txBody>
-                    <a:bodyPr/>
-                    <a:lstStyle/>
-                    <a:p>
-                      <a:pPr>
-                        <a:defRPr sz="950">
-                          <a:solidFill>
-                            <a:srgbClr val="1E1E1E"/>
-                          </a:solidFill>
-                        </a:defRPr>
-                      </a:pPr>
-                      <a:r>
-                        <a:t>阪急OASISマルシェ豊中駅前店</a:t>
-                      </a:r>
-                    </a:p>
-                  </a:txBody>
-                  <a:tcPr>
-                    <a:solidFill>
-                      <a:srgbClr val="F5F5F5"/>
-                    </a:solidFill>
-                  </a:tcPr>
-                </a:tc>
-                <a:tc>
-                  <a:txBody>
-                    <a:bodyPr/>
-                    <a:lstStyle/>
-                    <a:p>
-                      <a:pPr>
-                        <a:defRPr sz="950">
-                          <a:solidFill>
-                            <a:srgbClr val="1E1E1E"/>
-                          </a:solidFill>
-                        </a:defRPr>
-                      </a:pPr>
-                      <a:r>
-                        <a:t>2026年6月26日</a:t>
-                      </a:r>
-                    </a:p>
-                  </a:txBody>
-                  <a:tcPr>
-                    <a:solidFill>
-                      <a:srgbClr val="F5F5F5"/>
-                    </a:solidFill>
-                  </a:tcPr>
-                </a:tc>
-                <a:tc>
-                  <a:txBody>
-                    <a:bodyPr/>
-                    <a:lstStyle/>
-                    <a:p>
-                      <a:pPr>
-                        <a:defRPr sz="950">
-                          <a:solidFill>
-                            <a:srgbClr val="1E1E1E"/>
-                          </a:solidFill>
-                        </a:defRPr>
-                      </a:pPr>
-                      <a:r>
-                        <a:t>リニューアルオープン</a:t>
-                      </a:r>
-                    </a:p>
-                  </a:txBody>
-                  <a:tcPr>
-                    <a:solidFill>
-                      <a:srgbClr val="F5F5F5"/>
-                    </a:solidFill>
-                  </a:tcPr>
-                </a:tc>
-                <a:tc>
-                  <a:txBody>
-                    <a:bodyPr/>
-                    <a:lstStyle/>
-                    <a:p>
-                      <a:pPr>
-                        <a:defRPr sz="950">
-                          <a:solidFill>
-                            <a:srgbClr val="1E1E1E"/>
-                          </a:solidFill>
-                        </a:defRPr>
-                      </a:pPr>
-                      <a:r>
-                        <a:t>中</a:t>
-                      </a:r>
-                    </a:p>
-                  </a:txBody>
-                  <a:tcPr>
-                    <a:solidFill>
-                      <a:srgbClr val="F5F5F5"/>
-                    </a:solidFill>
-                  </a:tcPr>
-                </a:tc>
-                <a:tc>
-                  <a:txBody>
-                    <a:bodyPr/>
-                    <a:lstStyle/>
-                    <a:p>
-                      <a:pPr>
-                        <a:defRPr sz="950">
-                          <a:solidFill>
-                            <a:srgbClr val="1E1E1E"/>
-                          </a:solidFill>
-                        </a:defRPr>
-                      </a:pPr>
-                      <a:r>
-                        <a:t>阪急オアシス豊中駅前店が6月15日18時に一時休業し、6月26日に「価値訴求型」と「価格訴求型」を融合した「阪急OASISマルシェ豊中駅前店」としてリニューアルオープンする。</a:t>
-                      </a:r>
-                    </a:p>
-                  </a:txBody>
-                  <a:tcPr>
-                    <a:solidFill>
-                      <a:srgbClr val="F5F5F5"/>
-                    </a:solidFill>
-                  </a:tcPr>
-                </a:tc>
-              </a:tr>
-              <a:tr h="792480">
-                <a:tc>
-                  <a:txBody>
-                    <a:bodyPr/>
-                    <a:lstStyle/>
-                    <a:p>
-                      <a:pPr>
-                        <a:defRPr sz="950">
-                          <a:solidFill>
-                            <a:srgbClr val="1E1E1E"/>
-                          </a:solidFill>
-                        </a:defRPr>
-                      </a:pPr>
-                      <a:r>
-                        <a:t>大阪府豊中市</a:t>
-                      </a:r>
-                    </a:p>
-                  </a:txBody>
-                  <a:tcPr/>
-                </a:tc>
-                <a:tc>
-                  <a:txBody>
-                    <a:bodyPr/>
-                    <a:lstStyle/>
-                    <a:p>
-                      <a:pPr>
-                        <a:defRPr sz="950">
-                          <a:solidFill>
-                            <a:srgbClr val="1E1E1E"/>
-                          </a:solidFill>
-                        </a:defRPr>
-                      </a:pPr>
-                      <a:r>
-                        <a:t>阪急オアシス 服部西店</a:t>
-                      </a:r>
-                    </a:p>
-                  </a:txBody>
-                  <a:tcPr/>
-                </a:tc>
-                <a:tc>
-                  <a:txBody>
-                    <a:bodyPr/>
-                    <a:lstStyle/>
-                    <a:p>
-                      <a:pPr>
-                        <a:defRPr sz="950">
-                          <a:solidFill>
-                            <a:srgbClr val="1E1E1E"/>
-                          </a:solidFill>
-                        </a:defRPr>
-                      </a:pPr>
-                      <a:r>
-                        <a:t>2026年7月7日～7月16日</a:t>
-                      </a:r>
-                    </a:p>
-                  </a:txBody>
-                  <a:tcPr/>
-                </a:tc>
-                <a:tc>
-                  <a:txBody>
-                    <a:bodyPr/>
-                    <a:lstStyle/>
-                    <a:p>
-                      <a:pPr>
-                        <a:defRPr sz="950">
-                          <a:solidFill>
-                            <a:srgbClr val="1E1E1E"/>
-                          </a:solidFill>
-                        </a:defRPr>
-                      </a:pPr>
-                      <a:r>
-                        <a:t>臨時休業（改装の可能性あり）</a:t>
-                      </a:r>
-                    </a:p>
-                  </a:txBody>
-                  <a:tcPr/>
-                </a:tc>
-                <a:tc>
-                  <a:txBody>
-                    <a:bodyPr/>
-                    <a:lstStyle/>
-                    <a:p>
-                      <a:pPr>
-                        <a:defRPr sz="950">
-                          <a:solidFill>
-                            <a:srgbClr val="1E1E1E"/>
-                          </a:solidFill>
-                        </a:defRPr>
-                      </a:pPr>
-                      <a:r>
-                        <a:t>低</a:t>
-                      </a:r>
-                    </a:p>
-                  </a:txBody>
-                  <a:tcPr/>
-                </a:tc>
-                <a:tc>
-                  <a:txBody>
-                    <a:bodyPr/>
-                    <a:lstStyle/>
-                    <a:p>
-                      <a:pPr>
-                        <a:defRPr sz="950">
-                          <a:solidFill>
-                            <a:srgbClr val="1E1E1E"/>
-                          </a:solidFill>
-                        </a:defRPr>
-                      </a:pPr>
-                      <a:r>
-                        <a:t>阪急オアシス服部西店が設備点検・改装のため臨時休業予定。</a:t>
-                      </a:r>
-                    </a:p>
-                  </a:txBody>
-                  <a:tcPr/>
-                </a:tc>
-              </a:tr>
-              <a:tr h="792480">
-                <a:tc>
-                  <a:txBody>
-                    <a:bodyPr/>
-                    <a:lstStyle/>
-                    <a:p>
-                      <a:pPr>
-                        <a:defRPr sz="950">
-                          <a:solidFill>
-                            <a:srgbClr val="1E1E1E"/>
-                          </a:solidFill>
-                        </a:defRPr>
-                      </a:pPr>
-                      <a:r>
-                        <a:t>兵庫県神戸市灘区</a:t>
-                      </a:r>
-                    </a:p>
-                  </a:txBody>
-                  <a:tcPr>
-                    <a:solidFill>
-                      <a:srgbClr val="F5F5F5"/>
-                    </a:solidFill>
-                  </a:tcPr>
-                </a:tc>
-                <a:tc>
-                  <a:txBody>
-                    <a:bodyPr/>
-                    <a:lstStyle/>
-                    <a:p>
-                      <a:pPr>
-                        <a:defRPr sz="950">
-                          <a:solidFill>
-                            <a:srgbClr val="1E1E1E"/>
-                          </a:solidFill>
-                        </a:defRPr>
-                      </a:pPr>
-                      <a:r>
-                        <a:t>関西スーパー 西郷店</a:t>
-                      </a:r>
-                    </a:p>
-                  </a:txBody>
-                  <a:tcPr>
-                    <a:solidFill>
-                      <a:srgbClr val="F5F5F5"/>
-                    </a:solidFill>
-                  </a:tcPr>
-                </a:tc>
-                <a:tc>
-                  <a:txBody>
-                    <a:bodyPr/>
-                    <a:lstStyle/>
-                    <a:p>
-                      <a:pPr>
-                        <a:defRPr sz="950">
-                          <a:solidFill>
-                            <a:srgbClr val="1E1E1E"/>
-                          </a:solidFill>
-                        </a:defRPr>
-                      </a:pPr>
-                      <a:r>
-                        <a:t>2026年6月30日～7月2日</a:t>
-                      </a:r>
-                    </a:p>
-                  </a:txBody>
-                  <a:tcPr>
-                    <a:solidFill>
-                      <a:srgbClr val="F5F5F5"/>
-                    </a:solidFill>
-                  </a:tcPr>
-                </a:tc>
-                <a:tc>
-                  <a:txBody>
-                    <a:bodyPr/>
-                    <a:lstStyle/>
-                    <a:p>
-                      <a:pPr>
-                        <a:defRPr sz="950">
-                          <a:solidFill>
-                            <a:srgbClr val="1E1E1E"/>
-                          </a:solidFill>
-                        </a:defRPr>
-                      </a:pPr>
-                      <a:r>
-                        <a:t>臨時休業</a:t>
-                      </a:r>
-                    </a:p>
-                  </a:txBody>
-                  <a:tcPr>
-                    <a:solidFill>
-                      <a:srgbClr val="F5F5F5"/>
-                    </a:solidFill>
-                  </a:tcPr>
-                </a:tc>
-                <a:tc>
-                  <a:txBody>
-                    <a:bodyPr/>
-                    <a:lstStyle/>
-                    <a:p>
-                      <a:pPr>
-                        <a:defRPr sz="950">
-                          <a:solidFill>
-                            <a:srgbClr val="1E1E1E"/>
-                          </a:solidFill>
-                        </a:defRPr>
-                      </a:pPr>
-                      <a:r>
-                        <a:t>低</a:t>
-                      </a:r>
-                    </a:p>
-                  </a:txBody>
-                  <a:tcPr>
-                    <a:solidFill>
-                      <a:srgbClr val="F5F5F5"/>
-                    </a:solidFill>
-                  </a:tcPr>
-                </a:tc>
-                <a:tc>
-                  <a:txBody>
-                    <a:bodyPr/>
-                    <a:lstStyle/>
-                    <a:p/>
-                  </a:txBody>
-                  <a:tcPr/>
                 </a:tc>
               </a:tr>
             </a:tbl>
@@ -4249,7 +3978,7 @@
               </a:defRPr>
             </a:pPr>
             <a:r>
-              <a:t>*   成城石井イオンモール堺北花田店は、Osaka Metro御堂筋線北花田駅に直結するイオンモール内への出店であり、いかりスーパーの既存店舗が近隣にない場合でも、広域からの集客が見込まれる商業施設への出店であるため、いかりスーパーの品質志向の顧客層との競合が発生する可能性がある。</a:t>
+              <a:t>今回新たに判明した動向は、いかりスーパーマーケットの既存店舗網、特に大阪都心部と宝塚エリアにおける戦略的な立地を巡る動きが顕著です。</a:t>
             </a:r>
           </a:p>
           <a:p>
@@ -4264,7 +3993,7 @@
               </a:defRPr>
             </a:pPr>
             <a:r>
-              <a:t>*   ヤマダストアー大阪梅田店は、大阪駅直結という非常に高い利便性を持つ商業施設内に出店するため、いかりJR大阪駅店や近隣の梅田エリアのいかり店舗にとって、高品質志向の顧客層を巡る直接的な競合となる。</a:t>
+              <a:t>*   **大阪都心部（JR大阪店周辺）**: いかりJR大阪店はJR大阪駅直結の大丸梅田店に位置していますが、その地下2階にヤマダストアーが2026年今冬に出店します。これは文字通り「隣接」する形での直接競合を意味し、既存のいかりJR大阪店の商圏に大きな影響を与える可能性があります。また、いかりスーパーマーケット自身も淀屋橋駅直結の「淀屋橋ステーションワン店」を2026年7月にオープンすることで、JR大阪店から約1.5km圏内のビジネス街において、自社のプレゼンスをさらに高める動きを見せています。</a:t>
             </a:r>
           </a:p>
           <a:p>
@@ -4279,22 +4008,7 @@
               </a:defRPr>
             </a:pPr>
             <a:r>
-              <a:t>*   阪急OASISマルシェ豊中駅前店のリニューアルは、いかりスーパー豊中店と同一地域での競争力を強化するものであり、特に「マルシェ」タイプへの転換は品揃えや店舗体験の差別化を試みるものと推測される。</a:t>
-            </a:r>
-          </a:p>
-          <a:p>
-            <a:pPr>
-              <a:spcAft>
-                <a:spcPts val="1400"/>
-              </a:spcAft>
-              <a:defRPr sz="1400">
-                <a:solidFill>
-                  <a:srgbClr val="1E1E1E"/>
-                </a:solidFill>
-              </a:defRPr>
-            </a:pPr>
-            <a:r>
-              <a:t>*   阪急オアシス服部西店および関西スーパー西郷店の臨時休業は一時的なものではあるが、周辺のいかりスーパー店舗への短期的な顧客流入や、休業後のリニューアル内容によっては中長期的な競合環境の変化に繋がる可能性がある。</a:t>
+              <a:t>*   **宝塚エリア（阪急逆瀬川店周辺）**: いかり阪急逆瀬川店から約0.5～1km圏内の宝塚市伊孑志4丁目に、2027年春にヤマダストアー宝塚店（仮称）が出店予定です。このエリアは阪急逆瀬川駅から非常に近く、いかり阪急逆瀬川店の主要な顧客層と重複する可能性が高く、直接的な顧客獲得競争が激化すると考えられます。</a:t>
             </a:r>
           </a:p>
         </p:txBody>
@@ -4385,7 +4099,7 @@
               </a:defRPr>
             </a:pPr>
             <a:r>
-              <a:t>*   成城石井イオンモール堺北花田店の新規出店は、いかりスーパーが展開する大阪府内の店舗、特に郊外立地で高品質商品を求める顧客層に対して新たな選択肢を提供する。成城石井のブランド力と商品構成は、いかりスーパーと同様に「上質」「こだわり」を求める顧客層をターゲットとしており、品揃えの独自性やサービス強化による差別化が求められる。</a:t>
+              <a:t>今回新たに判明した競合動向は、以下のいかりスーパーの店舗に直接的な影響を与えると考えられます。</a:t>
             </a:r>
           </a:p>
           <a:p>
@@ -4400,7 +4114,7 @@
               </a:defRPr>
             </a:pPr>
             <a:r>
-              <a:t>*   ヤマダストアー大阪梅田店の大丸梅田店地下への出店は、いかりJR大阪駅店およびいかり大丸梅田店（仮称）にとって直接的な脅威となる。ヤマダストアーも高品質・こだわり商品を展開しており、百貨店内の高級食品フロアという立地で、いかりスーパーと同様の顧客層をターゲットとするため、品揃えの独自性や、ギフト需要への対応、特別な顧客体験の提供など、一層の差別化戦略が求められる。</a:t>
+              <a:t>*   **いかりJR大阪店**: ヤマダストアーが同じ大丸梅田店の地下2階にオープンすることは、いかりJR大阪店にとって最も直接的かつ大きな影響をもたらします。両社ともに高品質な食品を強みとしており、顧客の分散や価格競争の激化が避けられないでしょう。いかりJR大阪店は、品揃えのさらなる差別化や、独自のサービス強化、あるいはヤマダストアーとは異なるターゲット層への訴求を検討する必要があります。</a:t>
             </a:r>
           </a:p>
           <a:p>
@@ -4415,7 +4129,7 @@
               </a:defRPr>
             </a:pPr>
             <a:r>
-              <a:t>*   阪急OASISマルシェ豊中駅前店のリニューアルは、いかりスーパー豊中店にとって競争激化の要因となる。阪急オアシスが「価値訴求型」と「価格訴求型」のハイブリッド型店舗を目指すことで、いかりスーパーの持つ高品質ブランドイメージと、日常使いの利便性を両立させようとする動きに対応するため、いかりスーパーは独自の顧客体験や地域密着型サービスをさらに強化し、顧客ロイヤルティを維持・向上させる必要がある。</a:t>
+              <a:t>*   **いかり阪急逆瀬川店**: ヤマダストアー宝塚店（仮称）が約0.5～1km圏内に出店することで、いかり阪急逆瀬川店は直接的な商圏の重複と顧客獲得競争に直面します。ヤマダストアーの強みである「食へのこだわり」がいかりの顧客層と重なるため、いかり阪急逆瀬川店は、地域密着型サービスや、よりパーソナルな顧客体験の提供、または生鮮食品以外の強み（デリカ、ベーカリーなど）の強化により、顧客流出を防ぐ戦略が求められます。</a:t>
             </a:r>
           </a:p>
           <a:p>
@@ -4430,7 +4144,7 @@
               </a:defRPr>
             </a:pPr>
             <a:r>
-              <a:t>*   阪急オアシス服部西店および関西スーパー西郷店の臨時休業は短期間ではあるが、その間に周辺のいかりスーパー店舗への顧客の流動が生じる可能性がある。特に改装後の再オープンにおいては、いかりスーパーは改めて自店舗の魅力や強みを顧客に訴求し、流出した顧客の再獲得に努める必要がある。</a:t>
+              <a:t>*   **いかりスーパーマーケット 淀屋橋ステーションワン店**: 自社新規店舗のオープンは、大阪都心部でのいかりブランドの浸透を加速させる一方で、既存のいかりJR大阪店との顧客層の棲み分けや、相互送客の戦略的な設計が重要となります。淀屋橋エリアのビジネス層という明確なターゲットに対し、デリカや時短ニーズに対応した商品ラインナップの強化がいっそう求められるでしょう。</a:t>
             </a:r>
           </a:p>
         </p:txBody>
@@ -4538,7 +4252,7 @@
                 </a:solidFill>
                 <a:hlinkClick r:id="rId2"/>
               </a:rPr>
-              <a:t>兵庫:「ヤマダストアー」大阪進出、大丸梅田店「デパ地下」に店舗では最大級の規模でオープン…生鮮食品・店内調理品も 読売新聞</a:t>
+              <a:t>オーケーが25年兵庫に出す5店を公表 26年には大阪に7店出店 激流オンライン</a:t>
             </a:r>
           </a:p>
           <a:p>
@@ -4570,7 +4284,7 @@
                 </a:solidFill>
                 <a:hlinkClick r:id="rId3"/>
               </a:rPr>
-              <a:t>【大阪に初出店】兵庫で人気のスーパー「ヤマダストアー」が梅田のデパ地下に登場 リビングWeb</a:t>
+              <a:t>【2026年最新】ロピア関西出店予定まとめ！神戸・大阪の新店舗情報を解説 RICO's diary</a:t>
             </a:r>
           </a:p>
           <a:p>
@@ -4602,7 +4316,7 @@
                 </a:solidFill>
                 <a:hlinkClick r:id="rId4"/>
               </a:rPr>
-              <a:t>ヤマダストアー Wikipedia</a:t>
+              <a:t>関東の激安スーパー「オーケー」１１日神戸市灘区に開店…２０２６年の出店予定は？ | Lmaga.jp</a:t>
             </a:r>
           </a:p>
           <a:p>
@@ -4634,7 +4348,7 @@
                 </a:solidFill>
                 <a:hlinkClick r:id="rId5"/>
               </a:rPr>
-              <a:t>6月26日（金）「阪急OASISマルシェ豊中駅前店」としてリニューアルオープン！ | エトレとよなか</a:t>
+              <a:t>ディスカウント・スーパーマーケット「オーケー南津守店（関西8号店）」2026年4月15日(水)、 「オーケー今川店（関西9号店）」 2026年4月22日(水) 連続出店！ ～2026年は大阪府での展開を加速します！～ |</a:t>
             </a:r>
           </a:p>
           <a:p>
@@ -4666,7 +4380,391 @@
                 </a:solidFill>
                 <a:hlinkClick r:id="rId6"/>
               </a:rPr>
-              <a:t>成城石井、大阪府堺市に「成城石井 イオンモール堺北花田店」6月18日オープン</a:t>
+              <a:t>宝塚市の敷地１・１㌶超に商業店舗を計画／２６年２月に着工／ヤマダストアー | 建設ニュース</a:t>
+            </a:r>
+          </a:p>
+          <a:p>
+            <a:pPr>
+              <a:spcAft>
+                <a:spcPts val="800"/>
+              </a:spcAft>
+            </a:pPr>
+            <a:r>
+              <a:rPr sz="1200">
+                <a:solidFill>
+                  <a:srgbClr val="1E1E1E"/>
+                </a:solidFill>
+              </a:rPr>
+              <a:t>・ </a:t>
+            </a:r>
+            <a:r>
+              <a:rPr sz="1200">
+                <a:solidFill>
+                  <a:srgbClr val="1E1E1E"/>
+                </a:solidFill>
+              </a:rPr>
+              <a:t>  </a:t>
+            </a:r>
+            <a:r>
+              <a:rPr sz="1200" u="sng">
+                <a:solidFill>
+                  <a:srgbClr val="0066CC"/>
+                </a:solidFill>
+                <a:hlinkClick r:id="rId7"/>
+              </a:rPr>
+              <a:t>オーケー／大阪府に5月2店舗、8月・11月にも新店舗オープン</a:t>
+            </a:r>
+          </a:p>
+          <a:p>
+            <a:pPr>
+              <a:spcAft>
+                <a:spcPts val="800"/>
+              </a:spcAft>
+            </a:pPr>
+            <a:r>
+              <a:rPr sz="1200">
+                <a:solidFill>
+                  <a:srgbClr val="1E1E1E"/>
+                </a:solidFill>
+              </a:rPr>
+              <a:t>・ </a:t>
+            </a:r>
+            <a:r>
+              <a:rPr sz="1200">
+                <a:solidFill>
+                  <a:srgbClr val="1E1E1E"/>
+                </a:solidFill>
+              </a:rPr>
+              <a:t>  </a:t>
+            </a:r>
+            <a:r>
+              <a:rPr sz="1200" u="sng">
+                <a:solidFill>
+                  <a:srgbClr val="0066CC"/>
+                </a:solidFill>
+                <a:hlinkClick r:id="rId8"/>
+              </a:rPr>
+              <a:t>オーケーnews｜4月5月で関西に4店舗を出店/計11店舗体制 流通スーパーニュース</a:t>
+            </a:r>
+          </a:p>
+          <a:p>
+            <a:pPr>
+              <a:spcAft>
+                <a:spcPts val="800"/>
+              </a:spcAft>
+            </a:pPr>
+            <a:r>
+              <a:rPr sz="1200">
+                <a:solidFill>
+                  <a:srgbClr val="1E1E1E"/>
+                </a:solidFill>
+              </a:rPr>
+              <a:t>・ </a:t>
+            </a:r>
+            <a:r>
+              <a:rPr sz="1200">
+                <a:solidFill>
+                  <a:srgbClr val="1E1E1E"/>
+                </a:solidFill>
+              </a:rPr>
+              <a:t>  </a:t>
+            </a:r>
+            <a:r>
+              <a:rPr sz="1200" u="sng">
+                <a:solidFill>
+                  <a:srgbClr val="0066CC"/>
+                </a:solidFill>
+                <a:hlinkClick r:id="rId9"/>
+              </a:rPr>
+              <a:t>【大丸梅田店地２階食品フロア大規模刷新！】兵庫県で人気の「ヤマダストアー」が2026年今冬、大阪初出店！～百貨店の食品売場が新たなステージへ～ | 株式会社 大丸松坂屋百貨店のプレスリリース PR TIMES</a:t>
+            </a:r>
+          </a:p>
+          <a:p>
+            <a:pPr>
+              <a:spcAft>
+                <a:spcPts val="800"/>
+              </a:spcAft>
+            </a:pPr>
+            <a:r>
+              <a:rPr sz="1200">
+                <a:solidFill>
+                  <a:srgbClr val="1E1E1E"/>
+                </a:solidFill>
+              </a:rPr>
+              <a:t>・ </a:t>
+            </a:r>
+            <a:r>
+              <a:rPr sz="1200">
+                <a:solidFill>
+                  <a:srgbClr val="1E1E1E"/>
+                </a:solidFill>
+              </a:rPr>
+              <a:t>  </a:t>
+            </a:r>
+            <a:r>
+              <a:rPr sz="1200" u="sng">
+                <a:solidFill>
+                  <a:srgbClr val="0066CC"/>
+                </a:solidFill>
+                <a:hlinkClick r:id="rId10"/>
+              </a:rPr>
+              <a:t>兵庫の人気スーパー「ヤマダストアー」が大阪初上陸、2026年冬に「大丸梅田店」に最大店舗がオープン</a:t>
+            </a:r>
+          </a:p>
+          <a:p>
+            <a:pPr>
+              <a:spcAft>
+                <a:spcPts val="800"/>
+              </a:spcAft>
+            </a:pPr>
+            <a:r>
+              <a:rPr sz="1200">
+                <a:solidFill>
+                  <a:srgbClr val="1E1E1E"/>
+                </a:solidFill>
+              </a:rPr>
+              <a:t>・ </a:t>
+            </a:r>
+            <a:r>
+              <a:rPr sz="1200">
+                <a:solidFill>
+                  <a:srgbClr val="1E1E1E"/>
+                </a:solidFill>
+              </a:rPr>
+              <a:t>  </a:t>
+            </a:r>
+            <a:r>
+              <a:rPr sz="1200" u="sng">
+                <a:solidFill>
+                  <a:srgbClr val="0066CC"/>
+                </a:solidFill>
+                <a:hlinkClick r:id="rId11"/>
+              </a:rPr>
+              <a:t>ヤマダストアー宝塚店 2027年春開業！テナントは？最新情報も！ 出店ウォッチ</a:t>
+            </a:r>
+          </a:p>
+          <a:p>
+            <a:pPr>
+              <a:spcAft>
+                <a:spcPts val="800"/>
+              </a:spcAft>
+            </a:pPr>
+            <a:r>
+              <a:rPr sz="1200">
+                <a:solidFill>
+                  <a:srgbClr val="1E1E1E"/>
+                </a:solidFill>
+              </a:rPr>
+              <a:t>・ </a:t>
+            </a:r>
+            <a:r>
+              <a:rPr sz="1200">
+                <a:solidFill>
+                  <a:srgbClr val="1E1E1E"/>
+                </a:solidFill>
+              </a:rPr>
+              <a:t>  </a:t>
+            </a:r>
+            <a:r>
+              <a:rPr sz="1200" u="sng">
+                <a:solidFill>
+                  <a:srgbClr val="0066CC"/>
+                </a:solidFill>
+                <a:hlinkClick r:id="rId12"/>
+              </a:rPr>
+              <a:t>駅直結！淀屋橋エリア初出店「いかりスーパーマーケット 淀屋橋ステーションワン店」が7月6日（月）オープン (2026年6月17日掲載) ライブドアニュース</a:t>
+            </a:r>
+          </a:p>
+          <a:p>
+            <a:pPr>
+              <a:spcAft>
+                <a:spcPts val="800"/>
+              </a:spcAft>
+            </a:pPr>
+            <a:r>
+              <a:rPr sz="1200">
+                <a:solidFill>
+                  <a:srgbClr val="1E1E1E"/>
+                </a:solidFill>
+              </a:rPr>
+              <a:t>・ </a:t>
+            </a:r>
+            <a:r>
+              <a:rPr sz="1200">
+                <a:solidFill>
+                  <a:srgbClr val="1E1E1E"/>
+                </a:solidFill>
+              </a:rPr>
+              <a:t>  </a:t>
+            </a:r>
+            <a:r>
+              <a:rPr sz="1200" u="sng">
+                <a:solidFill>
+                  <a:srgbClr val="0066CC"/>
+                </a:solidFill>
+                <a:hlinkClick r:id="rId13"/>
+              </a:rPr>
+              <a:t>いかりスーパーマーケット「淀屋橋ステーションワン店」2026年7月6日（月）午前10時オープン（大阪メトロ「淀屋橋駅」直結） 関西散歩ブログ</a:t>
+            </a:r>
+          </a:p>
+          <a:p>
+            <a:pPr>
+              <a:spcAft>
+                <a:spcPts val="800"/>
+              </a:spcAft>
+            </a:pPr>
+            <a:r>
+              <a:rPr sz="1200">
+                <a:solidFill>
+                  <a:srgbClr val="1E1E1E"/>
+                </a:solidFill>
+              </a:rPr>
+              <a:t>・ </a:t>
+            </a:r>
+            <a:r>
+              <a:rPr sz="1200">
+                <a:solidFill>
+                  <a:srgbClr val="1E1E1E"/>
+                </a:solidFill>
+              </a:rPr>
+              <a:t>  </a:t>
+            </a:r>
+            <a:r>
+              <a:rPr sz="1200" u="sng">
+                <a:solidFill>
+                  <a:srgbClr val="0066CC"/>
+                </a:solidFill>
+                <a:hlinkClick r:id="rId14"/>
+              </a:rPr>
+              <a:t>【ご案内】「うな富士」「銀平」「鉄十」「いかりスーパーマーケット」のOPEN日について</a:t>
+            </a:r>
+          </a:p>
+          <a:p>
+            <a:pPr>
+              <a:spcAft>
+                <a:spcPts val="800"/>
+              </a:spcAft>
+            </a:pPr>
+            <a:r>
+              <a:rPr sz="1200">
+                <a:solidFill>
+                  <a:srgbClr val="1E1E1E"/>
+                </a:solidFill>
+              </a:rPr>
+              <a:t>・ </a:t>
+            </a:r>
+            <a:r>
+              <a:rPr sz="1200">
+                <a:solidFill>
+                  <a:srgbClr val="1E1E1E"/>
+                </a:solidFill>
+              </a:rPr>
+              <a:t>  </a:t>
+            </a:r>
+            <a:r>
+              <a:rPr sz="1200" u="sng">
+                <a:solidFill>
+                  <a:srgbClr val="0066CC"/>
+                </a:solidFill>
+                <a:hlinkClick r:id="rId15"/>
+              </a:rPr>
+              <a:t>ディスカウント・スーパーマーケット「オーケー」 大阪府での展開を加速！5月に「大東新田西町店」「豊中穂積店」を連続出店 ～2026年度は大阪府内に計7店舗の出店を予定</a:t>
+            </a:r>
+          </a:p>
+          <a:p>
+            <a:pPr>
+              <a:spcAft>
+                <a:spcPts val="800"/>
+              </a:spcAft>
+            </a:pPr>
+            <a:r>
+              <a:rPr sz="1200">
+                <a:solidFill>
+                  <a:srgbClr val="1E1E1E"/>
+                </a:solidFill>
+              </a:rPr>
+              <a:t>・ </a:t>
+            </a:r>
+            <a:r>
+              <a:rPr sz="1200">
+                <a:solidFill>
+                  <a:srgbClr val="1E1E1E"/>
+                </a:solidFill>
+              </a:rPr>
+              <a:t>  </a:t>
+            </a:r>
+            <a:r>
+              <a:rPr sz="1200" u="sng">
+                <a:solidFill>
+                  <a:srgbClr val="0066CC"/>
+                </a:solidFill>
+                <a:hlinkClick r:id="rId16"/>
+              </a:rPr>
+              <a:t>激安スーパーオーケー大阪出店はいつ？2026年までの全店舗オープン予定を解説</a:t>
+            </a:r>
+          </a:p>
+          <a:p>
+            <a:pPr>
+              <a:spcAft>
+                <a:spcPts val="800"/>
+              </a:spcAft>
+            </a:pPr>
+            <a:r>
+              <a:rPr sz="1200">
+                <a:solidFill>
+                  <a:srgbClr val="1E1E1E"/>
+                </a:solidFill>
+              </a:rPr>
+              <a:t>・ </a:t>
+            </a:r>
+            <a:r>
+              <a:rPr sz="1200">
+                <a:solidFill>
+                  <a:srgbClr val="1E1E1E"/>
+                </a:solidFill>
+              </a:rPr>
+              <a:t>  </a:t>
+            </a:r>
+            <a:r>
+              <a:rPr sz="1200" u="sng">
+                <a:solidFill>
+                  <a:srgbClr val="0066CC"/>
+                </a:solidFill>
+                <a:hlinkClick r:id="rId17"/>
+              </a:rPr>
+              <a:t>ヤマダストアー Wikipedia</a:t>
+            </a:r>
+          </a:p>
+          <a:p>
+            <a:pPr>
+              <a:spcAft>
+                <a:spcPts val="800"/>
+              </a:spcAft>
+            </a:pPr>
+            <a:r>
+              <a:rPr sz="1200">
+                <a:solidFill>
+                  <a:srgbClr val="1E1E1E"/>
+                </a:solidFill>
+              </a:rPr>
+              <a:t>・ </a:t>
+            </a:r>
+            <a:r>
+              <a:rPr sz="1200">
+                <a:solidFill>
+                  <a:srgbClr val="1E1E1E"/>
+                </a:solidFill>
+              </a:rPr>
+              <a:t>  </a:t>
+            </a:r>
+            <a:r>
+              <a:rPr sz="1200" u="sng">
+                <a:solidFill>
+                  <a:srgbClr val="0066CC"/>
+                </a:solidFill>
+                <a:hlinkClick r:id="rId18"/>
+              </a:rPr>
+              <a:t>関西地方 | 出店ウォッチ</a:t>
             </a:r>
           </a:p>
         </p:txBody>

</xml_diff>

<commit_message>
fix: remove ikari yodoyabashi store from competitive report
</commit_message>
<xml_diff>
--- a/report/2026_06_18_competitive_report.pptx
+++ b/report/2026_06_18_competitive_report.pptx
@@ -3238,21 +3238,6 @@
               </a:defRPr>
             </a:pPr>
             <a:r>
-              <a:t>・   2026年7月6日、いかりスーパーマーケットが大阪メトロ淀屋橋駅直結の「淀屋橋ステーションワン店」を新規オープンし、大阪都心部における自社店舗網を強化します。</a:t>
-            </a:r>
-          </a:p>
-          <a:p>
-            <a:pPr>
-              <a:spcAft>
-                <a:spcPts val="1600"/>
-              </a:spcAft>
-              <a:defRPr sz="1800">
-                <a:solidFill>
-                  <a:srgbClr val="1E1E1E"/>
-                </a:solidFill>
-              </a:defRPr>
-            </a:pPr>
-            <a:r>
               <a:t>・   ヤマダストアーが2026年今冬に「大丸梅田店」地下2階に大阪初出店を予定しており、いかりJR大阪店と競合する高級スーパー市場での競争が激化します。</a:t>
             </a:r>
           </a:p>
@@ -3352,7 +3337,7 @@
                 <a:gridCol w="1371600"/>
                 <a:gridCol w="4416552"/>
               </a:tblGrid>
-              <a:tr h="1188720">
+              <a:tr h="1584960">
                 <a:tc>
                   <a:txBody>
                     <a:bodyPr/>
@@ -3492,7 +3477,7 @@
                   </a:tcPr>
                 </a:tc>
               </a:tr>
-              <a:tr h="1188720">
+              <a:tr h="1584960">
                 <a:tc>
                   <a:txBody>
                     <a:bodyPr/>
@@ -3506,7 +3491,7 @@
                         </a:defRPr>
                       </a:pPr>
                       <a:r>
-                        <a:t>大阪市中央区（淀屋橋）</a:t>
+                        <a:t>大阪市北区（梅田）</a:t>
                       </a:r>
                     </a:p>
                   </a:txBody>
@@ -3529,7 +3514,7 @@
                         </a:defRPr>
                       </a:pPr>
                       <a:r>
-                        <a:t>いかりスーパーマーケット 淀屋橋ステーションワン店</a:t>
+                        <a:t>ヤマダストアー 大阪 梅田店</a:t>
                       </a:r>
                     </a:p>
                   </a:txBody>
@@ -3552,7 +3537,7 @@
                         </a:defRPr>
                       </a:pPr>
                       <a:r>
-                        <a:t>2026年7月6日（月）</a:t>
+                        <a:t>2026年今冬（後半）</a:t>
                       </a:r>
                     </a:p>
                   </a:txBody>
@@ -3598,7 +3583,7 @@
                         </a:defRPr>
                       </a:pPr>
                       <a:r>
-                        <a:t>内部強化（中）</a:t>
+                        <a:t>高</a:t>
                       </a:r>
                     </a:p>
                   </a:txBody>
@@ -3621,7 +3606,7 @@
                         </a:defRPr>
                       </a:pPr>
                       <a:r>
-                        <a:t>大阪メトロ淀屋橋駅・京阪淀屋橋駅直結の「淀屋橋ステーションワン」地下1階に、いかりスーパーマーケットの新店舗がオープン。いかりJR大阪店から約1.5km圏内で、ビジネス層や地域住民の利便性向上と、大阪都心部でのブランドプレゼンス強化を図ります。</a:t>
+                        <a:t>兵庫県を拠点とする高品質スーパー「ヤマダストアー」が、大丸梅田店地下2階に大阪初出店。いかりJR大阪店と同一ビル内での開業となり、高級食材やこだわりの商品に強みを持つ両者間で直接的な競合が発生します。</a:t>
                       </a:r>
                     </a:p>
                   </a:txBody>
@@ -3632,7 +3617,7 @@
                   </a:tcPr>
                 </a:tc>
               </a:tr>
-              <a:tr h="1188720">
+              <a:tr h="1584960">
                 <a:tc>
                   <a:txBody>
                     <a:bodyPr/>
@@ -3646,7 +3631,7 @@
                         </a:defRPr>
                       </a:pPr>
                       <a:r>
-                        <a:t>大阪市北区（梅田）</a:t>
+                        <a:t>兵庫県宝塚市（逆瀬川）</a:t>
                       </a:r>
                     </a:p>
                   </a:txBody>
@@ -3665,7 +3650,7 @@
                         </a:defRPr>
                       </a:pPr>
                       <a:r>
-                        <a:t>ヤマダストアー 大阪 梅田店</a:t>
+                        <a:t>ヤマダストアー宝塚店（仮称）</a:t>
                       </a:r>
                     </a:p>
                   </a:txBody>
@@ -3684,7 +3669,7 @@
                         </a:defRPr>
                       </a:pPr>
                       <a:r>
-                        <a:t>2026年今冬（後半）</a:t>
+                        <a:t>2027年春</a:t>
                       </a:r>
                     </a:p>
                   </a:txBody>
@@ -3722,7 +3707,7 @@
                         </a:defRPr>
                       </a:pPr>
                       <a:r>
-                        <a:t>高</a:t>
+                        <a:t>中</a:t>
                       </a:r>
                     </a:p>
                   </a:txBody>
@@ -3741,151 +3726,11 @@
                         </a:defRPr>
                       </a:pPr>
                       <a:r>
-                        <a:t>兵庫県を拠点とする高品質スーパー「ヤマダストアー」が、大丸梅田店地下2階に大阪初出店。いかりJR大阪店と同一ビル内での開業となり、高級食材やこだわりの商品に強みを持つ両者間で直接的な競合が発生します。</a:t>
+                        <a:t>兵庫県宝塚市伊孑志4丁目（阪急逆瀬川駅近く）に「ヤマダストアー宝塚店（仮称）」が開業予定。いかり阪急逆瀬川店から約0.5～1km圏内での出店となり、地域住民の取り合いが予想されます。</a:t>
                       </a:r>
                     </a:p>
                   </a:txBody>
                   <a:tcPr/>
-                </a:tc>
-              </a:tr>
-              <a:tr h="1188720">
-                <a:tc>
-                  <a:txBody>
-                    <a:bodyPr/>
-                    <a:lstStyle/>
-                    <a:p>
-                      <a:pPr>
-                        <a:defRPr sz="950">
-                          <a:solidFill>
-                            <a:srgbClr val="1E1E1E"/>
-                          </a:solidFill>
-                        </a:defRPr>
-                      </a:pPr>
-                      <a:r>
-                        <a:t>兵庫県宝塚市（逆瀬川）</a:t>
-                      </a:r>
-                    </a:p>
-                  </a:txBody>
-                  <a:tcPr>
-                    <a:solidFill>
-                      <a:srgbClr val="F5F5F5"/>
-                    </a:solidFill>
-                  </a:tcPr>
-                </a:tc>
-                <a:tc>
-                  <a:txBody>
-                    <a:bodyPr/>
-                    <a:lstStyle/>
-                    <a:p>
-                      <a:pPr>
-                        <a:defRPr sz="950">
-                          <a:solidFill>
-                            <a:srgbClr val="1E1E1E"/>
-                          </a:solidFill>
-                        </a:defRPr>
-                      </a:pPr>
-                      <a:r>
-                        <a:t>ヤマダストアー宝塚店（仮称）</a:t>
-                      </a:r>
-                    </a:p>
-                  </a:txBody>
-                  <a:tcPr>
-                    <a:solidFill>
-                      <a:srgbClr val="F5F5F5"/>
-                    </a:solidFill>
-                  </a:tcPr>
-                </a:tc>
-                <a:tc>
-                  <a:txBody>
-                    <a:bodyPr/>
-                    <a:lstStyle/>
-                    <a:p>
-                      <a:pPr>
-                        <a:defRPr sz="950">
-                          <a:solidFill>
-                            <a:srgbClr val="1E1E1E"/>
-                          </a:solidFill>
-                        </a:defRPr>
-                      </a:pPr>
-                      <a:r>
-                        <a:t>2027年春</a:t>
-                      </a:r>
-                    </a:p>
-                  </a:txBody>
-                  <a:tcPr>
-                    <a:solidFill>
-                      <a:srgbClr val="F5F5F5"/>
-                    </a:solidFill>
-                  </a:tcPr>
-                </a:tc>
-                <a:tc>
-                  <a:txBody>
-                    <a:bodyPr/>
-                    <a:lstStyle/>
-                    <a:p>
-                      <a:pPr>
-                        <a:defRPr sz="950">
-                          <a:solidFill>
-                            <a:srgbClr val="1E1E1E"/>
-                          </a:solidFill>
-                        </a:defRPr>
-                      </a:pPr>
-                      <a:r>
-                        <a:t>新規オープン</a:t>
-                      </a:r>
-                    </a:p>
-                  </a:txBody>
-                  <a:tcPr>
-                    <a:solidFill>
-                      <a:srgbClr val="F5F5F5"/>
-                    </a:solidFill>
-                  </a:tcPr>
-                </a:tc>
-                <a:tc>
-                  <a:txBody>
-                    <a:bodyPr/>
-                    <a:lstStyle/>
-                    <a:p>
-                      <a:pPr>
-                        <a:defRPr sz="950">
-                          <a:solidFill>
-                            <a:srgbClr val="1E1E1E"/>
-                          </a:solidFill>
-                        </a:defRPr>
-                      </a:pPr>
-                      <a:r>
-                        <a:t>中</a:t>
-                      </a:r>
-                    </a:p>
-                  </a:txBody>
-                  <a:tcPr>
-                    <a:solidFill>
-                      <a:srgbClr val="F5F5F5"/>
-                    </a:solidFill>
-                  </a:tcPr>
-                </a:tc>
-                <a:tc>
-                  <a:txBody>
-                    <a:bodyPr/>
-                    <a:lstStyle/>
-                    <a:p>
-                      <a:pPr>
-                        <a:defRPr sz="950">
-                          <a:solidFill>
-                            <a:srgbClr val="1E1E1E"/>
-                          </a:solidFill>
-                        </a:defRPr>
-                      </a:pPr>
-                      <a:r>
-                        <a:t>兵庫県宝塚市伊孑志4丁目（阪急逆瀬川駅近く）に「ヤマダストアー宝塚店（仮称）」が開業予定。いかり阪急逆瀬川店から約0.5～1km圏内での出店となり、地域住民の取り合いが予想されます。</a:t>
-                      </a:r>
-                    </a:p>
-                  </a:txBody>
-                  <a:tcPr>
-                    <a:solidFill>
-                      <a:srgbClr val="F5F5F5"/>
-                    </a:solidFill>
-                  </a:tcPr>
                 </a:tc>
               </a:tr>
             </a:tbl>
@@ -3978,7 +3823,7 @@
               </a:defRPr>
             </a:pPr>
             <a:r>
-              <a:t>今回新たに判明した動向は、いかりスーパーマーケットの既存店舗網、特に大阪都心部と宝塚エリアにおける戦略的な立地を巡る動きが顕著です。</a:t>
+              <a:t>今回新たに判明した動向は、大阪都心部と宝塚エリアにおけるいかり既存店周辺での競合動向が顕著です。</a:t>
             </a:r>
           </a:p>
           <a:p>
@@ -3993,7 +3838,7 @@
               </a:defRPr>
             </a:pPr>
             <a:r>
-              <a:t>*   **大阪都心部（JR大阪店周辺）**: いかりJR大阪店はJR大阪駅直結の大丸梅田店に位置していますが、その地下2階にヤマダストアーが2026年今冬に出店します。これは文字通り「隣接」する形での直接競合を意味し、既存のいかりJR大阪店の商圏に大きな影響を与える可能性があります。また、いかりスーパーマーケット自身も淀屋橋駅直結の「淀屋橋ステーションワン店」を2026年7月にオープンすることで、JR大阪店から約1.5km圏内のビジネス街において、自社のプレゼンスをさらに高める動きを見せています。</a:t>
+              <a:t>*   **大阪都心部（JR大阪店周辺）**: いかりJR大阪店はJR大阪駅直結の大丸梅田店に位置していますが、その地下2階にヤマダストアーが2026年今冬に出店します。これは文字通り「隣接」する形での直接競合を意味し、既存のいかりJR大阪店の商圏に大きな影響を与える可能性があります。</a:t>
             </a:r>
           </a:p>
           <a:p>
@@ -4132,21 +3977,6 @@
               <a:t>*   **いかり阪急逆瀬川店**: ヤマダストアー宝塚店（仮称）が約0.5～1km圏内に出店することで、いかり阪急逆瀬川店は直接的な商圏の重複と顧客獲得競争に直面します。ヤマダストアーの強みである「食へのこだわり」がいかりの顧客層と重なるため、いかり阪急逆瀬川店は、地域密着型サービスや、よりパーソナルな顧客体験の提供、または生鮮食品以外の強み（デリカ、ベーカリーなど）の強化により、顧客流出を防ぐ戦略が求められます。</a:t>
             </a:r>
           </a:p>
-          <a:p>
-            <a:pPr>
-              <a:spcAft>
-                <a:spcPts val="1200"/>
-              </a:spcAft>
-              <a:defRPr sz="1350">
-                <a:solidFill>
-                  <a:srgbClr val="1E1E1E"/>
-                </a:solidFill>
-              </a:defRPr>
-            </a:pPr>
-            <a:r>
-              <a:t>*   **いかりスーパーマーケット 淀屋橋ステーションワン店**: 自社新規店舗のオープンは、大阪都心部でのいかりブランドの浸透を加速させる一方で、既存のいかりJR大阪店との顧客層の棲み分けや、相互送客の戦略的な設計が重要となります。淀屋橋エリアのビジネス層という明確なターゲットに対し、デリカや時短ニーズに対応した商品ラインナップの強化がいっそう求められるでしょう。</a:t>
-            </a:r>
-          </a:p>
         </p:txBody>
       </p:sp>
     </p:spTree>
@@ -4444,7 +4274,7 @@
                 </a:solidFill>
                 <a:hlinkClick r:id="rId8"/>
               </a:rPr>
-              <a:t>オーケーnews｜4月5月で関西に4店舗を出店/計11店舗体制 流通スーパーニュース</a:t>
+              <a:t>オーケーnews／4月5月で関西に4店舗を出店/計11店舗体制 流通スーパーニュース</a:t>
             </a:r>
           </a:p>
           <a:p>
@@ -4572,7 +4402,7 @@
                 </a:solidFill>
                 <a:hlinkClick r:id="rId12"/>
               </a:rPr>
-              <a:t>駅直結！淀屋橋エリア初出店「いかりスーパーマーケット 淀屋橋ステーションワン店」が7月6日（月）オープン (2026年6月17日掲載) ライブドアニュース</a:t>
+              <a:t>ディスカウント・スーパーマーケット「オーケー」 大阪府での展開を加速！5月に「大東新田西町店」「豊中穂積店」を連続出店 ～2026年度は大阪府内に計7店舗の出店を予定</a:t>
             </a:r>
           </a:p>
           <a:p>
@@ -4604,7 +4434,7 @@
                 </a:solidFill>
                 <a:hlinkClick r:id="rId13"/>
               </a:rPr>
-              <a:t>いかりスーパーマーケット「淀屋橋ステーションワン店」2026年7月6日（月）午前10時オープン（大阪メトロ「淀屋橋駅」直結） 関西散歩ブログ</a:t>
+              <a:t>激安スーパーオーケー大阪出店はいつ？2026年までの全店舗オープン予定を解説</a:t>
             </a:r>
           </a:p>
           <a:p>
@@ -4636,7 +4466,7 @@
                 </a:solidFill>
                 <a:hlinkClick r:id="rId14"/>
               </a:rPr>
-              <a:t>【ご案内】「うな富士」「銀平」「鉄十」「いかりスーパーマーケット」のOPEN日について</a:t>
+              <a:t>ヤマダストアー Wikipedia</a:t>
             </a:r>
           </a:p>
           <a:p>
@@ -4667,102 +4497,6 @@
                   <a:srgbClr val="0066CC"/>
                 </a:solidFill>
                 <a:hlinkClick r:id="rId15"/>
-              </a:rPr>
-              <a:t>ディスカウント・スーパーマーケット「オーケー」 大阪府での展開を加速！5月に「大東新田西町店」「豊中穂積店」を連続出店 ～2026年度は大阪府内に計7店舗の出店を予定</a:t>
-            </a:r>
-          </a:p>
-          <a:p>
-            <a:pPr>
-              <a:spcAft>
-                <a:spcPts val="800"/>
-              </a:spcAft>
-            </a:pPr>
-            <a:r>
-              <a:rPr sz="1200">
-                <a:solidFill>
-                  <a:srgbClr val="1E1E1E"/>
-                </a:solidFill>
-              </a:rPr>
-              <a:t>・ </a:t>
-            </a:r>
-            <a:r>
-              <a:rPr sz="1200">
-                <a:solidFill>
-                  <a:srgbClr val="1E1E1E"/>
-                </a:solidFill>
-              </a:rPr>
-              <a:t>  </a:t>
-            </a:r>
-            <a:r>
-              <a:rPr sz="1200" u="sng">
-                <a:solidFill>
-                  <a:srgbClr val="0066CC"/>
-                </a:solidFill>
-                <a:hlinkClick r:id="rId16"/>
-              </a:rPr>
-              <a:t>激安スーパーオーケー大阪出店はいつ？2026年までの全店舗オープン予定を解説</a:t>
-            </a:r>
-          </a:p>
-          <a:p>
-            <a:pPr>
-              <a:spcAft>
-                <a:spcPts val="800"/>
-              </a:spcAft>
-            </a:pPr>
-            <a:r>
-              <a:rPr sz="1200">
-                <a:solidFill>
-                  <a:srgbClr val="1E1E1E"/>
-                </a:solidFill>
-              </a:rPr>
-              <a:t>・ </a:t>
-            </a:r>
-            <a:r>
-              <a:rPr sz="1200">
-                <a:solidFill>
-                  <a:srgbClr val="1E1E1E"/>
-                </a:solidFill>
-              </a:rPr>
-              <a:t>  </a:t>
-            </a:r>
-            <a:r>
-              <a:rPr sz="1200" u="sng">
-                <a:solidFill>
-                  <a:srgbClr val="0066CC"/>
-                </a:solidFill>
-                <a:hlinkClick r:id="rId17"/>
-              </a:rPr>
-              <a:t>ヤマダストアー Wikipedia</a:t>
-            </a:r>
-          </a:p>
-          <a:p>
-            <a:pPr>
-              <a:spcAft>
-                <a:spcPts val="800"/>
-              </a:spcAft>
-            </a:pPr>
-            <a:r>
-              <a:rPr sz="1200">
-                <a:solidFill>
-                  <a:srgbClr val="1E1E1E"/>
-                </a:solidFill>
-              </a:rPr>
-              <a:t>・ </a:t>
-            </a:r>
-            <a:r>
-              <a:rPr sz="1200">
-                <a:solidFill>
-                  <a:srgbClr val="1E1E1E"/>
-                </a:solidFill>
-              </a:rPr>
-              <a:t>  </a:t>
-            </a:r>
-            <a:r>
-              <a:rPr sz="1200" u="sng">
-                <a:solidFill>
-                  <a:srgbClr val="0066CC"/>
-                </a:solidFill>
-                <a:hlinkClick r:id="rId18"/>
               </a:rPr>
               <a:t>関西地方 | 出店ウォッチ</a:t>
             </a:r>

</xml_diff>

<commit_message>
feat: add affected store column to competitive report table
</commit_message>
<xml_diff>
--- a/report/2026_06_18_competitive_report.pptx
+++ b/report/2026_06_18_competitive_report.pptx
@@ -3331,11 +3331,12 @@
               </a:tblPr>
               <a:tblGrid>
                 <a:gridCol w="914400"/>
-                <a:gridCol w="2011680"/>
-                <a:gridCol w="1188720"/>
+                <a:gridCol w="1645920"/>
+                <a:gridCol w="914400"/>
                 <a:gridCol w="914400"/>
                 <a:gridCol w="1371600"/>
-                <a:gridCol w="4416552"/>
+                <a:gridCol w="914400"/>
+                <a:gridCol w="4142232"/>
               </a:tblGrid>
               <a:tr h="1584960">
                 <a:tc>
@@ -3421,6 +3422,29 @@
                       </a:pPr>
                       <a:r>
                         <a:t>状態</a:t>
+                      </a:r>
+                    </a:p>
+                  </a:txBody>
+                  <a:tcPr>
+                    <a:solidFill>
+                      <a:srgbClr val="004628"/>
+                    </a:solidFill>
+                  </a:tcPr>
+                </a:tc>
+                <a:tc>
+                  <a:txBody>
+                    <a:bodyPr/>
+                    <a:lstStyle/>
+                    <a:p>
+                      <a:pPr algn="ctr">
+                        <a:defRPr b="1" sz="1100">
+                          <a:solidFill>
+                            <a:srgbClr val="FFFFFF"/>
+                          </a:solidFill>
+                        </a:defRPr>
+                      </a:pPr>
+                      <a:r>
+                        <a:t>影響店舗</a:t>
                       </a:r>
                     </a:p>
                   </a:txBody>
@@ -3583,6 +3607,29 @@
                         </a:defRPr>
                       </a:pPr>
                       <a:r>
+                        <a:t>いかりJR大阪店</a:t>
+                      </a:r>
+                    </a:p>
+                  </a:txBody>
+                  <a:tcPr>
+                    <a:solidFill>
+                      <a:srgbClr val="F5F5F5"/>
+                    </a:solidFill>
+                  </a:tcPr>
+                </a:tc>
+                <a:tc>
+                  <a:txBody>
+                    <a:bodyPr/>
+                    <a:lstStyle/>
+                    <a:p>
+                      <a:pPr>
+                        <a:defRPr sz="950">
+                          <a:solidFill>
+                            <a:srgbClr val="1E1E1E"/>
+                          </a:solidFill>
+                        </a:defRPr>
+                      </a:pPr>
+                      <a:r>
                         <a:t>高</a:t>
                       </a:r>
                     </a:p>
@@ -3689,6 +3736,25 @@
                       </a:pPr>
                       <a:r>
                         <a:t>新規オープン</a:t>
+                      </a:r>
+                    </a:p>
+                  </a:txBody>
+                  <a:tcPr/>
+                </a:tc>
+                <a:tc>
+                  <a:txBody>
+                    <a:bodyPr/>
+                    <a:lstStyle/>
+                    <a:p>
+                      <a:pPr>
+                        <a:defRPr sz="950">
+                          <a:solidFill>
+                            <a:srgbClr val="1E1E1E"/>
+                          </a:solidFill>
+                        </a:defRPr>
+                      </a:pPr>
+                      <a:r>
+                        <a:t>いかり阪急逆瀬川店</a:t>
                       </a:r>
                     </a:p>
                   </a:txBody>

</xml_diff>

<commit_message>
fix: list all affected stores within 2km in detailed table
</commit_message>
<xml_diff>
--- a/report/2026_06_18_competitive_report.pptx
+++ b/report/2026_06_18_competitive_report.pptx
@@ -3754,7 +3754,7 @@
                         </a:defRPr>
                       </a:pPr>
                       <a:r>
-                        <a:t>いかり阪急逆瀬川店</a:t>
+                        <a:t>いかり宝塚店、いかり阪急逆瀬川店</a:t>
                       </a:r>
                     </a:p>
                   </a:txBody>
@@ -3792,7 +3792,7 @@
                         </a:defRPr>
                       </a:pPr>
                       <a:r>
-                        <a:t>兵庫県宝塚市伊孑志4丁目（阪急逆瀬川駅近く）に「ヤマダストアー宝塚店（仮称）」が開業予定。いかり阪急逆瀬川店から約0.5～1km圏内での出店となり、地域住民の取り合いが予想されます。</a:t>
+                        <a:t>兵庫県宝塚市伊孑志4丁目（阪急逆瀬川駅近く）に「ヤマダストアー宝塚店（仮称）」が開業予定。いかり宝塚店および逆瀬川店から約0.5～1km圏内での出店となり、地域住民の取り合いが予想されます。</a:t>
                       </a:r>
                     </a:p>
                   </a:txBody>

</xml_diff>